<commit_message>
Increase all font sizes by 2pt (body 18pt, title 74pt, subtitle 22pt)
Text remains in standard editable placeholders/textboxes (fully editable
in PowerPoint). Content and corrections unchanged.
</commit_message>
<xml_diff>
--- a/Sapna_Ahirwar_Case_Conference.pptx
+++ b/Sapna_Ahirwar_Case_Conference.pptx
@@ -5216,7 +5216,7 @@
           <a:p>
             <a:pPr algn="ctr"/>
             <a:r>
-              <a:rPr lang="en-US" sz="7200" b="1" dirty="0">
+              <a:rPr lang="en-US" sz="7400" b="1" dirty="0">
                 <a:solidFill>
                   <a:schemeClr val="tx1"/>
                 </a:solidFill>
@@ -5252,7 +5252,7 @@
           <a:p>
             <a:pPr algn="ctr"/>
             <a:r>
-              <a:rPr lang="en-US" sz="2000" dirty="0">
+              <a:rPr lang="en-US" sz="2200" dirty="0">
                 <a:solidFill>
                   <a:schemeClr val="tx1"/>
                 </a:solidFill>
@@ -5265,7 +5265,7 @@
           <a:p>
             <a:pPr algn="ctr"/>
             <a:r>
-              <a:rPr lang="en-US" sz="2000" dirty="0">
+              <a:rPr lang="en-US" sz="2200" dirty="0">
                 <a:solidFill>
                   <a:schemeClr val="tx1"/>
                 </a:solidFill>
@@ -5285,7 +5285,7 @@
           <a:p>
             <a:pPr algn="ctr"/>
             <a:r>
-              <a:rPr lang="en-US" sz="2000" dirty="0">
+              <a:rPr lang="en-US" sz="2200" dirty="0">
                 <a:solidFill>
                   <a:schemeClr val="tx1"/>
                 </a:solidFill>
@@ -5298,7 +5298,7 @@
           <a:p>
             <a:pPr algn="ctr"/>
             <a:r>
-              <a:rPr lang="en-US" sz="2000" dirty="0">
+              <a:rPr lang="en-US" sz="2200" dirty="0">
                 <a:solidFill>
                   <a:schemeClr val="tx1"/>
                 </a:solidFill>
@@ -5401,7 +5401,7 @@
               </a:lnSpc>
             </a:pPr>
             <a:r>
-              <a:rPr lang="en-US" sz="1600" b="1" dirty="0">
+              <a:rPr lang="en-US" sz="1800" b="1" dirty="0">
                 <a:latin typeface="Times New Roman" panose="02020603050405020304" pitchFamily="18" charset="0"/>
                 <a:cs typeface="Times New Roman" panose="02020603050405020304" pitchFamily="18" charset="0"/>
               </a:rPr>
@@ -5415,7 +5415,7 @@
               </a:lnSpc>
             </a:pPr>
             <a:r>
-              <a:rPr lang="en-US" sz="1600" dirty="0">
+              <a:rPr lang="en-US" sz="1800" dirty="0">
                 <a:latin typeface="Times New Roman" panose="02020603050405020304" pitchFamily="18" charset="0"/>
                 <a:cs typeface="Times New Roman" panose="02020603050405020304" pitchFamily="18" charset="0"/>
               </a:rPr>
@@ -5429,14 +5429,14 @@
               </a:lnSpc>
             </a:pPr>
             <a:r>
-              <a:rPr lang="en-US" sz="1600" b="1" dirty="0">
+              <a:rPr lang="en-US" sz="1800" b="1" dirty="0">
                 <a:latin typeface="Times New Roman" panose="02020603050405020304" pitchFamily="18" charset="0"/>
                 <a:cs typeface="Times New Roman" panose="02020603050405020304" pitchFamily="18" charset="0"/>
               </a:rPr>
               <a:t>Medical History: </a:t>
             </a:r>
             <a:r>
-              <a:rPr lang="en-US" sz="1600" dirty="0">
+              <a:rPr lang="en-US" sz="1800" dirty="0">
                 <a:latin typeface="Times New Roman" panose="02020603050405020304" pitchFamily="18" charset="0"/>
                 <a:cs typeface="Times New Roman" panose="02020603050405020304" pitchFamily="18" charset="0"/>
               </a:rPr>
@@ -5450,14 +5450,14 @@
               </a:lnSpc>
             </a:pPr>
             <a:r>
-              <a:rPr lang="en-US" sz="1600" b="1" dirty="0">
+              <a:rPr lang="en-US" sz="1800" b="1" dirty="0">
                 <a:latin typeface="Times New Roman" panose="02020603050405020304" pitchFamily="18" charset="0"/>
                 <a:cs typeface="Times New Roman" panose="02020603050405020304" pitchFamily="18" charset="0"/>
               </a:rPr>
               <a:t>Psychiatric History: </a:t>
             </a:r>
             <a:r>
-              <a:rPr lang="en-US" sz="1600" dirty="0">
+              <a:rPr lang="en-US" sz="1800" dirty="0">
                 <a:latin typeface="Times New Roman" panose="02020603050405020304" pitchFamily="18" charset="0"/>
                 <a:cs typeface="Times New Roman" panose="02020603050405020304" pitchFamily="18" charset="0"/>
               </a:rPr>
@@ -5543,7 +5543,7 @@
               </a:lnSpc>
             </a:pPr>
             <a:r>
-              <a:rPr lang="en-US" sz="1600" b="1" dirty="0">
+              <a:rPr lang="en-US" sz="1800" b="1" dirty="0">
                 <a:latin typeface="Times New Roman" panose="02020603050405020304" pitchFamily="18" charset="0"/>
                 <a:cs typeface="Times New Roman" panose="02020603050405020304" pitchFamily="18" charset="0"/>
               </a:rPr>
@@ -5557,7 +5557,7 @@
               </a:lnSpc>
             </a:pPr>
             <a:r>
-              <a:rPr lang="en-US" sz="1600" dirty="0">
+              <a:rPr lang="en-US" sz="1800" dirty="0">
                 <a:latin typeface="Times New Roman" panose="02020603050405020304" pitchFamily="18" charset="0"/>
                 <a:cs typeface="Times New Roman" panose="02020603050405020304" pitchFamily="18" charset="0"/>
               </a:rPr>
@@ -5571,14 +5571,14 @@
               </a:lnSpc>
             </a:pPr>
             <a:r>
-              <a:rPr lang="en-US" sz="1600" b="1" dirty="0">
+              <a:rPr lang="en-US" sz="1800" b="1" dirty="0">
                 <a:latin typeface="Times New Roman" panose="02020603050405020304" pitchFamily="18" charset="0"/>
                 <a:cs typeface="Times New Roman" panose="02020603050405020304" pitchFamily="18" charset="0"/>
               </a:rPr>
               <a:t>Family History of Medical/Psychiatric Disorders: </a:t>
             </a:r>
             <a:r>
-              <a:rPr lang="en-US" sz="1600" dirty="0">
+              <a:rPr lang="en-US" sz="1800" dirty="0">
                 <a:latin typeface="Times New Roman" panose="02020603050405020304" pitchFamily="18" charset="0"/>
                 <a:cs typeface="Times New Roman" panose="02020603050405020304" pitchFamily="18" charset="0"/>
               </a:rPr>
@@ -5592,14 +5592,14 @@
               </a:lnSpc>
             </a:pPr>
             <a:r>
-              <a:rPr lang="en-US" sz="1600" b="1" dirty="0">
+              <a:rPr lang="en-US" sz="1800" b="1" dirty="0">
                 <a:latin typeface="Times New Roman" panose="02020603050405020304" pitchFamily="18" charset="0"/>
                 <a:cs typeface="Times New Roman" panose="02020603050405020304" pitchFamily="18" charset="0"/>
               </a:rPr>
               <a:t>Primary Caregiver: </a:t>
             </a:r>
             <a:r>
-              <a:rPr lang="en-US" sz="1600" dirty="0">
+              <a:rPr lang="en-US" sz="1800" dirty="0">
                 <a:latin typeface="Times New Roman" panose="02020603050405020304" pitchFamily="18" charset="0"/>
                 <a:cs typeface="Times New Roman" panose="02020603050405020304" pitchFamily="18" charset="0"/>
               </a:rPr>
@@ -5613,14 +5613,14 @@
               </a:lnSpc>
             </a:pPr>
             <a:r>
-              <a:rPr lang="en-US" sz="1600" b="1" dirty="0">
+              <a:rPr lang="en-US" sz="1800" b="1" dirty="0">
                 <a:latin typeface="Times New Roman" panose="02020603050405020304" pitchFamily="18" charset="0"/>
                 <a:cs typeface="Times New Roman" panose="02020603050405020304" pitchFamily="18" charset="0"/>
               </a:rPr>
               <a:t>Type of Communication: </a:t>
             </a:r>
             <a:r>
-              <a:rPr lang="en-US" sz="1600" dirty="0">
+              <a:rPr lang="en-US" sz="1800" dirty="0">
                 <a:latin typeface="Times New Roman" panose="02020603050405020304" pitchFamily="18" charset="0"/>
                 <a:cs typeface="Times New Roman" panose="02020603050405020304" pitchFamily="18" charset="0"/>
               </a:rPr>
@@ -5634,14 +5634,14 @@
               </a:lnSpc>
             </a:pPr>
             <a:r>
-              <a:rPr lang="en-US" sz="1600" b="1" dirty="0">
+              <a:rPr lang="en-US" sz="1800" b="1" dirty="0">
                 <a:latin typeface="Times New Roman" panose="02020603050405020304" pitchFamily="18" charset="0"/>
                 <a:cs typeface="Times New Roman" panose="02020603050405020304" pitchFamily="18" charset="0"/>
               </a:rPr>
               <a:t>Family Understanding of Illness: </a:t>
             </a:r>
             <a:r>
-              <a:rPr lang="en-US" sz="1600" dirty="0">
+              <a:rPr lang="en-US" sz="1800" dirty="0">
                 <a:latin typeface="Times New Roman" panose="02020603050405020304" pitchFamily="18" charset="0"/>
                 <a:cs typeface="Times New Roman" panose="02020603050405020304" pitchFamily="18" charset="0"/>
               </a:rPr>
@@ -5655,14 +5655,14 @@
               </a:lnSpc>
             </a:pPr>
             <a:r>
-              <a:rPr lang="en-US" sz="1600" b="1" dirty="0">
+              <a:rPr lang="en-US" sz="1800" b="1" dirty="0">
                 <a:latin typeface="Times New Roman" panose="02020603050405020304" pitchFamily="18" charset="0"/>
                 <a:cs typeface="Times New Roman" panose="02020603050405020304" pitchFamily="18" charset="0"/>
               </a:rPr>
               <a:t>Family Members’ Attitude Towards the Patient: </a:t>
             </a:r>
             <a:r>
-              <a:rPr lang="en-US" sz="1600" dirty="0">
+              <a:rPr lang="en-US" sz="1800" dirty="0">
                 <a:latin typeface="Times New Roman" panose="02020603050405020304" pitchFamily="18" charset="0"/>
                 <a:cs typeface="Times New Roman" panose="02020603050405020304" pitchFamily="18" charset="0"/>
               </a:rPr>
@@ -5676,14 +5676,14 @@
               </a:lnSpc>
             </a:pPr>
             <a:r>
-              <a:rPr lang="en-US" sz="1600" b="1" dirty="0">
+              <a:rPr lang="en-US" sz="1800" b="1" dirty="0">
                 <a:latin typeface="Times New Roman" panose="02020603050405020304" pitchFamily="18" charset="0"/>
                 <a:cs typeface="Times New Roman" panose="02020603050405020304" pitchFamily="18" charset="0"/>
               </a:rPr>
               <a:t>Family Stressors and Discords: </a:t>
             </a:r>
             <a:r>
-              <a:rPr lang="en-US" sz="1600" dirty="0">
+              <a:rPr lang="en-US" sz="1800" dirty="0">
                 <a:latin typeface="Times New Roman" panose="02020603050405020304" pitchFamily="18" charset="0"/>
                 <a:cs typeface="Times New Roman" panose="02020603050405020304" pitchFamily="18" charset="0"/>
               </a:rPr>
@@ -5769,7 +5769,7 @@
               </a:lnSpc>
             </a:pPr>
             <a:r>
-              <a:rPr lang="en-US" sz="1600" b="1" dirty="0">
+              <a:rPr lang="en-US" sz="1800" b="1" dirty="0">
                 <a:latin typeface="Times New Roman" panose="02020603050405020304" pitchFamily="18" charset="0"/>
                 <a:cs typeface="Times New Roman" panose="02020603050405020304" pitchFamily="18" charset="0"/>
               </a:rPr>
@@ -5783,7 +5783,7 @@
               </a:lnSpc>
             </a:pPr>
             <a:r>
-              <a:rPr lang="en-US" sz="1600" dirty="0">
+              <a:rPr lang="en-US" sz="1800" dirty="0">
                 <a:latin typeface="Times New Roman" panose="02020603050405020304" pitchFamily="18" charset="0"/>
                 <a:cs typeface="Times New Roman" panose="02020603050405020304" pitchFamily="18" charset="0"/>
               </a:rPr>
@@ -5797,14 +5797,14 @@
               </a:lnSpc>
             </a:pPr>
             <a:r>
-              <a:rPr lang="en-US" sz="1600" b="1" dirty="0">
+              <a:rPr lang="en-US" sz="1800" b="1" dirty="0">
                 <a:latin typeface="Times New Roman" panose="02020603050405020304" pitchFamily="18" charset="0"/>
                 <a:cs typeface="Times New Roman" panose="02020603050405020304" pitchFamily="18" charset="0"/>
               </a:rPr>
               <a:t>Birth and Early Development: </a:t>
             </a:r>
             <a:r>
-              <a:rPr lang="en-US" sz="1600" dirty="0">
+              <a:rPr lang="en-US" sz="1800" dirty="0">
                 <a:latin typeface="Times New Roman" panose="02020603050405020304" pitchFamily="18" charset="0"/>
                 <a:cs typeface="Times New Roman" panose="02020603050405020304" pitchFamily="18" charset="0"/>
               </a:rPr>
@@ -5818,14 +5818,14 @@
               </a:lnSpc>
             </a:pPr>
             <a:r>
-              <a:rPr lang="en-US" sz="1600" b="1" dirty="0">
+              <a:rPr lang="en-US" sz="1800" b="1" dirty="0">
                 <a:latin typeface="Times New Roman" panose="02020603050405020304" pitchFamily="18" charset="0"/>
                 <a:cs typeface="Times New Roman" panose="02020603050405020304" pitchFamily="18" charset="0"/>
               </a:rPr>
               <a:t>Behaviour During Childhood: </a:t>
             </a:r>
             <a:r>
-              <a:rPr lang="en-US" sz="1600" dirty="0">
+              <a:rPr lang="en-US" sz="1800" dirty="0">
                 <a:latin typeface="Times New Roman" panose="02020603050405020304" pitchFamily="18" charset="0"/>
                 <a:cs typeface="Times New Roman" panose="02020603050405020304" pitchFamily="18" charset="0"/>
               </a:rPr>
@@ -5839,14 +5839,14 @@
               </a:lnSpc>
             </a:pPr>
             <a:r>
-              <a:rPr lang="en-US" sz="1600" b="1" dirty="0">
+              <a:rPr lang="en-US" sz="1800" b="1" dirty="0">
                 <a:latin typeface="Times New Roman" panose="02020603050405020304" pitchFamily="18" charset="0"/>
                 <a:cs typeface="Times New Roman" panose="02020603050405020304" pitchFamily="18" charset="0"/>
               </a:rPr>
               <a:t>Physical Illness During Childhood: </a:t>
             </a:r>
             <a:r>
-              <a:rPr lang="en-US" sz="1600" dirty="0">
+              <a:rPr lang="en-US" sz="1800" dirty="0">
                 <a:latin typeface="Times New Roman" panose="02020603050405020304" pitchFamily="18" charset="0"/>
                 <a:cs typeface="Times New Roman" panose="02020603050405020304" pitchFamily="18" charset="0"/>
               </a:rPr>
@@ -5932,7 +5932,7 @@
               </a:lnSpc>
             </a:pPr>
             <a:r>
-              <a:rPr lang="en-US" sz="1600" b="1" dirty="0">
+              <a:rPr lang="en-US" sz="1800" b="1" dirty="0">
                 <a:latin typeface="Times New Roman" panose="02020603050405020304" pitchFamily="18" charset="0"/>
                 <a:cs typeface="Times New Roman" panose="02020603050405020304" pitchFamily="18" charset="0"/>
               </a:rPr>
@@ -5946,7 +5946,7 @@
               </a:lnSpc>
             </a:pPr>
             <a:r>
-              <a:rPr lang="en-US" sz="1600" dirty="0">
+              <a:rPr lang="en-US" sz="1800" dirty="0">
                 <a:latin typeface="Times New Roman" panose="02020603050405020304" pitchFamily="18" charset="0"/>
                 <a:cs typeface="Times New Roman" panose="02020603050405020304" pitchFamily="18" charset="0"/>
               </a:rPr>
@@ -5960,14 +5960,14 @@
               </a:lnSpc>
             </a:pPr>
             <a:r>
-              <a:rPr lang="en-US" sz="1600" b="1" dirty="0">
+              <a:rPr lang="en-US" sz="1800" b="1" dirty="0">
                 <a:latin typeface="Times New Roman" panose="02020603050405020304" pitchFamily="18" charset="0"/>
                 <a:cs typeface="Times New Roman" panose="02020603050405020304" pitchFamily="18" charset="0"/>
               </a:rPr>
               <a:t>Home Atmosphere During Childhood and Adolescence: </a:t>
             </a:r>
             <a:r>
-              <a:rPr lang="en-US" sz="1600" dirty="0">
+              <a:rPr lang="en-US" sz="1800" dirty="0">
                 <a:latin typeface="Times New Roman" panose="02020603050405020304" pitchFamily="18" charset="0"/>
                 <a:cs typeface="Times New Roman" panose="02020603050405020304" pitchFamily="18" charset="0"/>
               </a:rPr>
@@ -5981,14 +5981,14 @@
               </a:lnSpc>
             </a:pPr>
             <a:r>
-              <a:rPr lang="en-US" sz="1600" b="1" dirty="0">
+              <a:rPr lang="en-US" sz="1800" b="1" dirty="0">
                 <a:latin typeface="Times New Roman" panose="02020603050405020304" pitchFamily="18" charset="0"/>
                 <a:cs typeface="Times New Roman" panose="02020603050405020304" pitchFamily="18" charset="0"/>
               </a:rPr>
               <a:t>Scholastic and Extracurricular Activities: </a:t>
             </a:r>
             <a:r>
-              <a:rPr lang="en-US" sz="1600" dirty="0">
+              <a:rPr lang="en-US" sz="1800" dirty="0">
                 <a:latin typeface="Times New Roman" panose="02020603050405020304" pitchFamily="18" charset="0"/>
                 <a:cs typeface="Times New Roman" panose="02020603050405020304" pitchFamily="18" charset="0"/>
               </a:rPr>
@@ -6002,14 +6002,14 @@
               </a:lnSpc>
             </a:pPr>
             <a:r>
-              <a:rPr lang="en-US" sz="1600" b="1" dirty="0">
+              <a:rPr lang="en-US" sz="1800" b="1" dirty="0">
                 <a:latin typeface="Times New Roman" panose="02020603050405020304" pitchFamily="18" charset="0"/>
                 <a:cs typeface="Times New Roman" panose="02020603050405020304" pitchFamily="18" charset="0"/>
               </a:rPr>
               <a:t>Occupation: </a:t>
             </a:r>
             <a:r>
-              <a:rPr lang="en-US" sz="1600" dirty="0">
+              <a:rPr lang="en-US" sz="1800" dirty="0">
                 <a:latin typeface="Times New Roman" panose="02020603050405020304" pitchFamily="18" charset="0"/>
                 <a:cs typeface="Times New Roman" panose="02020603050405020304" pitchFamily="18" charset="0"/>
               </a:rPr>
@@ -6023,14 +6023,14 @@
               </a:lnSpc>
             </a:pPr>
             <a:r>
-              <a:rPr lang="en-US" sz="1600" b="1" dirty="0">
+              <a:rPr lang="en-US" sz="1800" b="1" dirty="0">
                 <a:latin typeface="Times New Roman" panose="02020603050405020304" pitchFamily="18" charset="0"/>
                 <a:cs typeface="Times New Roman" panose="02020603050405020304" pitchFamily="18" charset="0"/>
               </a:rPr>
               <a:t>Menstrual History: </a:t>
             </a:r>
             <a:r>
-              <a:rPr lang="en-US" sz="1600" dirty="0">
+              <a:rPr lang="en-US" sz="1800" dirty="0">
                 <a:latin typeface="Times New Roman" panose="02020603050405020304" pitchFamily="18" charset="0"/>
                 <a:cs typeface="Times New Roman" panose="02020603050405020304" pitchFamily="18" charset="0"/>
               </a:rPr>
@@ -6044,14 +6044,14 @@
               </a:lnSpc>
             </a:pPr>
             <a:r>
-              <a:rPr lang="en-US" sz="1600" b="1" dirty="0">
+              <a:rPr lang="en-US" sz="1800" b="1" dirty="0">
                 <a:latin typeface="Times New Roman" panose="02020603050405020304" pitchFamily="18" charset="0"/>
                 <a:cs typeface="Times New Roman" panose="02020603050405020304" pitchFamily="18" charset="0"/>
               </a:rPr>
               <a:t>Sexual/Masturbation History: </a:t>
             </a:r>
             <a:r>
-              <a:rPr lang="en-US" sz="1600" dirty="0">
+              <a:rPr lang="en-US" sz="1800" dirty="0">
                 <a:latin typeface="Times New Roman" panose="02020603050405020304" pitchFamily="18" charset="0"/>
                 <a:cs typeface="Times New Roman" panose="02020603050405020304" pitchFamily="18" charset="0"/>
               </a:rPr>
@@ -6065,14 +6065,14 @@
               </a:lnSpc>
             </a:pPr>
             <a:r>
-              <a:rPr lang="en-US" sz="1600" b="1" dirty="0">
+              <a:rPr lang="en-US" sz="1800" b="1" dirty="0">
                 <a:latin typeface="Times New Roman" panose="02020603050405020304" pitchFamily="18" charset="0"/>
                 <a:cs typeface="Times New Roman" panose="02020603050405020304" pitchFamily="18" charset="0"/>
               </a:rPr>
               <a:t>Marital History: </a:t>
             </a:r>
             <a:r>
-              <a:rPr lang="en-US" sz="1600" dirty="0">
+              <a:rPr lang="en-US" sz="1800" dirty="0">
                 <a:latin typeface="Times New Roman" panose="02020603050405020304" pitchFamily="18" charset="0"/>
                 <a:cs typeface="Times New Roman" panose="02020603050405020304" pitchFamily="18" charset="0"/>
               </a:rPr>
@@ -6086,14 +6086,14 @@
               </a:lnSpc>
             </a:pPr>
             <a:r>
-              <a:rPr lang="en-US" sz="1600" b="1" dirty="0">
+              <a:rPr lang="en-US" sz="1800" b="1" dirty="0">
                 <a:latin typeface="Times New Roman" panose="02020603050405020304" pitchFamily="18" charset="0"/>
                 <a:cs typeface="Times New Roman" panose="02020603050405020304" pitchFamily="18" charset="0"/>
               </a:rPr>
               <a:t>Substance Use History: </a:t>
             </a:r>
             <a:r>
-              <a:rPr lang="en-US" sz="1600" dirty="0">
+              <a:rPr lang="en-US" sz="1800" dirty="0">
                 <a:latin typeface="Times New Roman" panose="02020603050405020304" pitchFamily="18" charset="0"/>
                 <a:cs typeface="Times New Roman" panose="02020603050405020304" pitchFamily="18" charset="0"/>
               </a:rPr>
@@ -6107,14 +6107,14 @@
               </a:lnSpc>
             </a:pPr>
             <a:r>
-              <a:rPr lang="en-US" sz="1600" b="1" dirty="0">
+              <a:rPr lang="en-US" sz="1800" b="1" dirty="0">
                 <a:latin typeface="Times New Roman" panose="02020603050405020304" pitchFamily="18" charset="0"/>
                 <a:cs typeface="Times New Roman" panose="02020603050405020304" pitchFamily="18" charset="0"/>
               </a:rPr>
               <a:t>Forensic History: </a:t>
             </a:r>
             <a:r>
-              <a:rPr lang="en-US" sz="1600" dirty="0">
+              <a:rPr lang="en-US" sz="1800" dirty="0">
                 <a:latin typeface="Times New Roman" panose="02020603050405020304" pitchFamily="18" charset="0"/>
                 <a:cs typeface="Times New Roman" panose="02020603050405020304" pitchFamily="18" charset="0"/>
               </a:rPr>
@@ -6200,7 +6200,7 @@
               </a:lnSpc>
             </a:pPr>
             <a:r>
-              <a:rPr lang="en-US" sz="1600" b="1" dirty="0">
+              <a:rPr lang="en-US" sz="1800" b="1" dirty="0">
                 <a:latin typeface="Times New Roman" panose="02020603050405020304" pitchFamily="18" charset="0"/>
                 <a:cs typeface="Times New Roman" panose="02020603050405020304" pitchFamily="18" charset="0"/>
               </a:rPr>
@@ -6214,7 +6214,7 @@
               </a:lnSpc>
             </a:pPr>
             <a:r>
-              <a:rPr lang="en-US" sz="1600" dirty="0">
+              <a:rPr lang="en-US" sz="1800" dirty="0">
                 <a:latin typeface="Times New Roman" panose="02020603050405020304" pitchFamily="18" charset="0"/>
                 <a:cs typeface="Times New Roman" panose="02020603050405020304" pitchFamily="18" charset="0"/>
               </a:rPr>
@@ -6228,7 +6228,7 @@
               </a:lnSpc>
             </a:pPr>
             <a:r>
-              <a:rPr lang="en-US" sz="1600" dirty="0">
+              <a:rPr lang="en-US" sz="1800" dirty="0">
                 <a:latin typeface="Times New Roman" panose="02020603050405020304" pitchFamily="18" charset="0"/>
                 <a:cs typeface="Times New Roman" panose="02020603050405020304" pitchFamily="18" charset="0"/>
               </a:rPr>
@@ -6314,7 +6314,7 @@
               </a:lnSpc>
             </a:pPr>
             <a:r>
-              <a:rPr lang="en-US" sz="1600" b="1" dirty="0">
+              <a:rPr lang="en-US" sz="1800" b="1" dirty="0">
                 <a:latin typeface="Times New Roman" panose="02020603050405020304" pitchFamily="18" charset="0"/>
                 <a:cs typeface="Times New Roman" panose="02020603050405020304" pitchFamily="18" charset="0"/>
               </a:rPr>
@@ -6328,7 +6328,7 @@
               </a:lnSpc>
             </a:pPr>
             <a:r>
-              <a:rPr lang="en-US" sz="1600" dirty="0">
+              <a:rPr lang="en-US" sz="1800" dirty="0">
                 <a:latin typeface="Times New Roman" panose="02020603050405020304" pitchFamily="18" charset="0"/>
                 <a:cs typeface="Times New Roman" panose="02020603050405020304" pitchFamily="18" charset="0"/>
               </a:rPr>
@@ -6342,7 +6342,7 @@
               </a:lnSpc>
             </a:pPr>
             <a:r>
-              <a:rPr lang="en-US" sz="1600" dirty="0">
+              <a:rPr lang="en-US" sz="1800" dirty="0">
                 <a:latin typeface="Times New Roman" panose="02020603050405020304" pitchFamily="18" charset="0"/>
                 <a:cs typeface="Times New Roman" panose="02020603050405020304" pitchFamily="18" charset="0"/>
               </a:rPr>
@@ -6428,7 +6428,7 @@
               </a:lnSpc>
             </a:pPr>
             <a:r>
-              <a:rPr lang="en-US" sz="1600" b="1" dirty="0">
+              <a:rPr lang="en-US" sz="1800" b="1" dirty="0">
                 <a:latin typeface="Times New Roman" panose="02020603050405020304" pitchFamily="18" charset="0"/>
                 <a:cs typeface="Times New Roman" panose="02020603050405020304" pitchFamily="18" charset="0"/>
               </a:rPr>
@@ -6442,7 +6442,7 @@
               </a:lnSpc>
             </a:pPr>
             <a:r>
-              <a:rPr lang="en-US" sz="1600" b="1" dirty="0">
+              <a:rPr lang="en-US" sz="1800" b="1" dirty="0">
                 <a:latin typeface="Times New Roman" panose="02020603050405020304" pitchFamily="18" charset="0"/>
                 <a:cs typeface="Times New Roman" panose="02020603050405020304" pitchFamily="18" charset="0"/>
               </a:rPr>
@@ -6456,7 +6456,7 @@
               </a:lnSpc>
             </a:pPr>
             <a:r>
-              <a:rPr lang="en-US" sz="1600" dirty="0">
+              <a:rPr lang="en-US" sz="1800" dirty="0">
                 <a:latin typeface="Times New Roman" panose="02020603050405020304" pitchFamily="18" charset="0"/>
                 <a:cs typeface="Times New Roman" panose="02020603050405020304" pitchFamily="18" charset="0"/>
               </a:rPr>
@@ -6470,14 +6470,14 @@
               </a:lnSpc>
             </a:pPr>
             <a:r>
-              <a:rPr lang="en-US" sz="1600" b="1" dirty="0">
+              <a:rPr lang="en-US" sz="1800" b="1" dirty="0">
                 <a:latin typeface="Times New Roman" panose="02020603050405020304" pitchFamily="18" charset="0"/>
                 <a:cs typeface="Times New Roman" panose="02020603050405020304" pitchFamily="18" charset="0"/>
               </a:rPr>
               <a:t>Physical Appearance: </a:t>
             </a:r>
             <a:r>
-              <a:rPr lang="en-US" sz="1600" dirty="0">
+              <a:rPr lang="en-US" sz="1800" dirty="0">
                 <a:latin typeface="Times New Roman" panose="02020603050405020304" pitchFamily="18" charset="0"/>
                 <a:cs typeface="Times New Roman" panose="02020603050405020304" pitchFamily="18" charset="0"/>
               </a:rPr>
@@ -6491,14 +6491,14 @@
               </a:lnSpc>
             </a:pPr>
             <a:r>
-              <a:rPr lang="en-US" sz="1600" b="1" dirty="0">
+              <a:rPr lang="en-US" sz="1800" b="1" dirty="0">
                 <a:latin typeface="Times New Roman" panose="02020603050405020304" pitchFamily="18" charset="0"/>
                 <a:cs typeface="Times New Roman" panose="02020603050405020304" pitchFamily="18" charset="0"/>
               </a:rPr>
               <a:t>Entry into the Room: </a:t>
             </a:r>
             <a:r>
-              <a:rPr lang="en-US" sz="1600" dirty="0">
+              <a:rPr lang="en-US" sz="1800" dirty="0">
                 <a:latin typeface="Times New Roman" panose="02020603050405020304" pitchFamily="18" charset="0"/>
                 <a:cs typeface="Times New Roman" panose="02020603050405020304" pitchFamily="18" charset="0"/>
               </a:rPr>
@@ -6512,14 +6512,14 @@
               </a:lnSpc>
             </a:pPr>
             <a:r>
-              <a:rPr lang="en-US" sz="1600" b="1" dirty="0">
+              <a:rPr lang="en-US" sz="1800" b="1" dirty="0">
                 <a:latin typeface="Times New Roman" panose="02020603050405020304" pitchFamily="18" charset="0"/>
                 <a:cs typeface="Times New Roman" panose="02020603050405020304" pitchFamily="18" charset="0"/>
               </a:rPr>
               <a:t>Facial Expression and Body Language: </a:t>
             </a:r>
             <a:r>
-              <a:rPr lang="en-US" sz="1600" dirty="0">
+              <a:rPr lang="en-US" sz="1800" dirty="0">
                 <a:latin typeface="Times New Roman" panose="02020603050405020304" pitchFamily="18" charset="0"/>
                 <a:cs typeface="Times New Roman" panose="02020603050405020304" pitchFamily="18" charset="0"/>
               </a:rPr>
@@ -6533,14 +6533,14 @@
               </a:lnSpc>
             </a:pPr>
             <a:r>
-              <a:rPr lang="en-US" sz="1600" b="1" dirty="0">
+              <a:rPr lang="en-US" sz="1800" b="1" dirty="0">
                 <a:latin typeface="Times New Roman" panose="02020603050405020304" pitchFamily="18" charset="0"/>
                 <a:cs typeface="Times New Roman" panose="02020603050405020304" pitchFamily="18" charset="0"/>
               </a:rPr>
               <a:t>Personal Hygiene: </a:t>
             </a:r>
             <a:r>
-              <a:rPr lang="en-US" sz="1600" dirty="0">
+              <a:rPr lang="en-US" sz="1800" dirty="0">
                 <a:latin typeface="Times New Roman" panose="02020603050405020304" pitchFamily="18" charset="0"/>
                 <a:cs typeface="Times New Roman" panose="02020603050405020304" pitchFamily="18" charset="0"/>
               </a:rPr>
@@ -6626,7 +6626,7 @@
               </a:lnSpc>
             </a:pPr>
             <a:r>
-              <a:rPr lang="en-US" sz="1600" b="1" dirty="0">
+              <a:rPr lang="en-US" sz="1800" b="1" dirty="0">
                 <a:latin typeface="Times New Roman" panose="02020603050405020304" pitchFamily="18" charset="0"/>
                 <a:cs typeface="Times New Roman" panose="02020603050405020304" pitchFamily="18" charset="0"/>
               </a:rPr>
@@ -6640,7 +6640,7 @@
               </a:lnSpc>
             </a:pPr>
             <a:r>
-              <a:rPr lang="en-US" sz="1600" dirty="0">
+              <a:rPr lang="en-US" sz="1800" dirty="0">
                 <a:latin typeface="Times New Roman" panose="02020603050405020304" pitchFamily="18" charset="0"/>
                 <a:cs typeface="Times New Roman" panose="02020603050405020304" pitchFamily="18" charset="0"/>
               </a:rPr>
@@ -6654,14 +6654,14 @@
               </a:lnSpc>
             </a:pPr>
             <a:r>
-              <a:rPr lang="en-US" sz="1600" b="1" dirty="0">
+              <a:rPr lang="en-US" sz="1800" b="1" dirty="0">
                 <a:latin typeface="Times New Roman" panose="02020603050405020304" pitchFamily="18" charset="0"/>
                 <a:cs typeface="Times New Roman" panose="02020603050405020304" pitchFamily="18" charset="0"/>
               </a:rPr>
               <a:t>Eye Contact: </a:t>
             </a:r>
             <a:r>
-              <a:rPr lang="en-US" sz="1600" dirty="0">
+              <a:rPr lang="en-US" sz="1800" dirty="0">
                 <a:latin typeface="Times New Roman" panose="02020603050405020304" pitchFamily="18" charset="0"/>
                 <a:cs typeface="Times New Roman" panose="02020603050405020304" pitchFamily="18" charset="0"/>
               </a:rPr>
@@ -6675,14 +6675,14 @@
               </a:lnSpc>
             </a:pPr>
             <a:r>
-              <a:rPr lang="en-US" sz="1600" b="1" dirty="0">
+              <a:rPr lang="en-US" sz="1800" b="1" dirty="0">
                 <a:latin typeface="Times New Roman" panose="02020603050405020304" pitchFamily="18" charset="0"/>
                 <a:cs typeface="Times New Roman" panose="02020603050405020304" pitchFamily="18" charset="0"/>
               </a:rPr>
               <a:t>Attitude Towards the Examiner: </a:t>
             </a:r>
             <a:r>
-              <a:rPr lang="en-US" sz="1600" dirty="0">
+              <a:rPr lang="en-US" sz="1800" dirty="0">
                 <a:latin typeface="Times New Roman" panose="02020603050405020304" pitchFamily="18" charset="0"/>
                 <a:cs typeface="Times New Roman" panose="02020603050405020304" pitchFamily="18" charset="0"/>
               </a:rPr>
@@ -6696,14 +6696,14 @@
               </a:lnSpc>
             </a:pPr>
             <a:r>
-              <a:rPr lang="en-US" sz="1600" b="1" dirty="0">
+              <a:rPr lang="en-US" sz="1800" b="1" dirty="0">
                 <a:latin typeface="Times New Roman" panose="02020603050405020304" pitchFamily="18" charset="0"/>
                 <a:cs typeface="Times New Roman" panose="02020603050405020304" pitchFamily="18" charset="0"/>
               </a:rPr>
               <a:t>Rapport: </a:t>
             </a:r>
             <a:r>
-              <a:rPr lang="en-US" sz="1600" dirty="0">
+              <a:rPr lang="en-US" sz="1800" dirty="0">
                 <a:latin typeface="Times New Roman" panose="02020603050405020304" pitchFamily="18" charset="0"/>
                 <a:cs typeface="Times New Roman" panose="02020603050405020304" pitchFamily="18" charset="0"/>
               </a:rPr>
@@ -6717,14 +6717,14 @@
               </a:lnSpc>
             </a:pPr>
             <a:r>
-              <a:rPr lang="en-US" sz="1600" b="1" dirty="0">
+              <a:rPr lang="en-US" sz="1800" b="1" dirty="0">
                 <a:latin typeface="Times New Roman" panose="02020603050405020304" pitchFamily="18" charset="0"/>
                 <a:cs typeface="Times New Roman" panose="02020603050405020304" pitchFamily="18" charset="0"/>
               </a:rPr>
               <a:t>Behaviour During the Interview: </a:t>
             </a:r>
             <a:r>
-              <a:rPr lang="en-US" sz="1600" dirty="0">
+              <a:rPr lang="en-US" sz="1800" dirty="0">
                 <a:latin typeface="Times New Roman" panose="02020603050405020304" pitchFamily="18" charset="0"/>
                 <a:cs typeface="Times New Roman" panose="02020603050405020304" pitchFamily="18" charset="0"/>
               </a:rPr>
@@ -6738,14 +6738,14 @@
               </a:lnSpc>
             </a:pPr>
             <a:r>
-              <a:rPr lang="en-US" sz="1600" b="1" dirty="0">
+              <a:rPr lang="en-US" sz="1800" b="1" dirty="0">
                 <a:latin typeface="Times New Roman" panose="02020603050405020304" pitchFamily="18" charset="0"/>
                 <a:cs typeface="Times New Roman" panose="02020603050405020304" pitchFamily="18" charset="0"/>
               </a:rPr>
               <a:t>Psychomotor Activity: </a:t>
             </a:r>
             <a:r>
-              <a:rPr lang="en-US" sz="1600" dirty="0">
+              <a:rPr lang="en-US" sz="1800" dirty="0">
                 <a:latin typeface="Times New Roman" panose="02020603050405020304" pitchFamily="18" charset="0"/>
                 <a:cs typeface="Times New Roman" panose="02020603050405020304" pitchFamily="18" charset="0"/>
               </a:rPr>
@@ -6831,7 +6831,7 @@
               </a:lnSpc>
             </a:pPr>
             <a:r>
-              <a:rPr lang="en-US" sz="1600" b="1" dirty="0">
+              <a:rPr lang="en-US" sz="1800" b="1" dirty="0">
                 <a:latin typeface="Times New Roman" panose="02020603050405020304" pitchFamily="18" charset="0"/>
                 <a:cs typeface="Times New Roman" panose="02020603050405020304" pitchFamily="18" charset="0"/>
               </a:rPr>
@@ -6845,7 +6845,7 @@
               </a:lnSpc>
             </a:pPr>
             <a:r>
-              <a:rPr lang="en-US" sz="1600" dirty="0">
+              <a:rPr lang="en-US" sz="1800" dirty="0">
                 <a:latin typeface="Times New Roman" panose="02020603050405020304" pitchFamily="18" charset="0"/>
                 <a:cs typeface="Times New Roman" panose="02020603050405020304" pitchFamily="18" charset="0"/>
               </a:rPr>
@@ -6859,14 +6859,14 @@
               </a:lnSpc>
             </a:pPr>
             <a:r>
-              <a:rPr lang="en-US" sz="1600" b="1" dirty="0">
+              <a:rPr lang="en-US" sz="1800" b="1" dirty="0">
                 <a:latin typeface="Times New Roman" panose="02020603050405020304" pitchFamily="18" charset="0"/>
                 <a:cs typeface="Times New Roman" panose="02020603050405020304" pitchFamily="18" charset="0"/>
               </a:rPr>
               <a:t>Coherence: </a:t>
             </a:r>
             <a:r>
-              <a:rPr lang="en-US" sz="1600" dirty="0">
+              <a:rPr lang="en-US" sz="1800" dirty="0">
                 <a:latin typeface="Times New Roman" panose="02020603050405020304" pitchFamily="18" charset="0"/>
                 <a:cs typeface="Times New Roman" panose="02020603050405020304" pitchFamily="18" charset="0"/>
               </a:rPr>
@@ -6880,14 +6880,14 @@
               </a:lnSpc>
             </a:pPr>
             <a:r>
-              <a:rPr lang="en-US" sz="1600" b="1" dirty="0">
+              <a:rPr lang="en-US" sz="1800" b="1" dirty="0">
                 <a:latin typeface="Times New Roman" panose="02020603050405020304" pitchFamily="18" charset="0"/>
                 <a:cs typeface="Times New Roman" panose="02020603050405020304" pitchFamily="18" charset="0"/>
               </a:rPr>
               <a:t>Relevance: </a:t>
             </a:r>
             <a:r>
-              <a:rPr lang="en-US" sz="1600" dirty="0">
+              <a:rPr lang="en-US" sz="1800" dirty="0">
                 <a:latin typeface="Times New Roman" panose="02020603050405020304" pitchFamily="18" charset="0"/>
                 <a:cs typeface="Times New Roman" panose="02020603050405020304" pitchFamily="18" charset="0"/>
               </a:rPr>
@@ -6901,14 +6901,14 @@
               </a:lnSpc>
             </a:pPr>
             <a:r>
-              <a:rPr lang="en-US" sz="1600" b="1" dirty="0">
+              <a:rPr lang="en-US" sz="1800" b="1" dirty="0">
                 <a:latin typeface="Times New Roman" panose="02020603050405020304" pitchFamily="18" charset="0"/>
                 <a:cs typeface="Times New Roman" panose="02020603050405020304" pitchFamily="18" charset="0"/>
               </a:rPr>
               <a:t>Tone: </a:t>
             </a:r>
             <a:r>
-              <a:rPr lang="en-US" sz="1600" dirty="0">
+              <a:rPr lang="en-US" sz="1800" dirty="0">
                 <a:latin typeface="Times New Roman" panose="02020603050405020304" pitchFamily="18" charset="0"/>
                 <a:cs typeface="Times New Roman" panose="02020603050405020304" pitchFamily="18" charset="0"/>
               </a:rPr>
@@ -6922,14 +6922,14 @@
               </a:lnSpc>
             </a:pPr>
             <a:r>
-              <a:rPr lang="en-US" sz="1600" b="1" dirty="0">
+              <a:rPr lang="en-US" sz="1800" b="1" dirty="0">
                 <a:latin typeface="Times New Roman" panose="02020603050405020304" pitchFamily="18" charset="0"/>
                 <a:cs typeface="Times New Roman" panose="02020603050405020304" pitchFamily="18" charset="0"/>
               </a:rPr>
               <a:t>Tempo: </a:t>
             </a:r>
             <a:r>
-              <a:rPr lang="en-US" sz="1600" dirty="0">
+              <a:rPr lang="en-US" sz="1800" dirty="0">
                 <a:latin typeface="Times New Roman" panose="02020603050405020304" pitchFamily="18" charset="0"/>
                 <a:cs typeface="Times New Roman" panose="02020603050405020304" pitchFamily="18" charset="0"/>
               </a:rPr>
@@ -6943,14 +6943,14 @@
               </a:lnSpc>
             </a:pPr>
             <a:r>
-              <a:rPr lang="en-US" sz="1600" b="1" dirty="0">
+              <a:rPr lang="en-US" sz="1800" b="1" dirty="0">
                 <a:latin typeface="Times New Roman" panose="02020603050405020304" pitchFamily="18" charset="0"/>
                 <a:cs typeface="Times New Roman" panose="02020603050405020304" pitchFamily="18" charset="0"/>
               </a:rPr>
               <a:t>Reaction Time: </a:t>
             </a:r>
             <a:r>
-              <a:rPr lang="en-US" sz="1600" dirty="0">
+              <a:rPr lang="en-US" sz="1800" dirty="0">
                 <a:latin typeface="Times New Roman" panose="02020603050405020304" pitchFamily="18" charset="0"/>
                 <a:cs typeface="Times New Roman" panose="02020603050405020304" pitchFamily="18" charset="0"/>
               </a:rPr>
@@ -6964,14 +6964,14 @@
               </a:lnSpc>
             </a:pPr>
             <a:r>
-              <a:rPr lang="en-US" sz="1600" b="1" dirty="0">
+              <a:rPr lang="en-US" sz="1800" b="1" dirty="0">
                 <a:latin typeface="Times New Roman" panose="02020603050405020304" pitchFamily="18" charset="0"/>
                 <a:cs typeface="Times New Roman" panose="02020603050405020304" pitchFamily="18" charset="0"/>
               </a:rPr>
               <a:t>Volume: </a:t>
             </a:r>
             <a:r>
-              <a:rPr lang="en-US" sz="1600" dirty="0">
+              <a:rPr lang="en-US" sz="1800" dirty="0">
                 <a:latin typeface="Times New Roman" panose="02020603050405020304" pitchFamily="18" charset="0"/>
                 <a:cs typeface="Times New Roman" panose="02020603050405020304" pitchFamily="18" charset="0"/>
               </a:rPr>
@@ -7057,7 +7057,7 @@
               </a:lnSpc>
             </a:pPr>
             <a:r>
-              <a:rPr lang="en-US" sz="1600" b="1" dirty="0">
+              <a:rPr lang="en-US" sz="1800" b="1" dirty="0">
                 <a:latin typeface="Times New Roman" panose="02020603050405020304" pitchFamily="18" charset="0"/>
                 <a:cs typeface="Times New Roman" panose="02020603050405020304" pitchFamily="18" charset="0"/>
               </a:rPr>
@@ -7071,7 +7071,7 @@
               </a:lnSpc>
             </a:pPr>
             <a:r>
-              <a:rPr lang="en-US" sz="1600" dirty="0">
+              <a:rPr lang="en-US" sz="1800" dirty="0">
                 <a:latin typeface="Times New Roman" panose="02020603050405020304" pitchFamily="18" charset="0"/>
                 <a:cs typeface="Times New Roman" panose="02020603050405020304" pitchFamily="18" charset="0"/>
               </a:rPr>
@@ -7085,14 +7085,14 @@
               </a:lnSpc>
             </a:pPr>
             <a:r>
-              <a:rPr lang="en-US" sz="1600" b="1" dirty="0">
+              <a:rPr lang="en-US" sz="1800" b="1" dirty="0">
                 <a:latin typeface="Times New Roman" panose="02020603050405020304" pitchFamily="18" charset="0"/>
                 <a:cs typeface="Times New Roman" panose="02020603050405020304" pitchFamily="18" charset="0"/>
               </a:rPr>
               <a:t>Form: </a:t>
             </a:r>
             <a:r>
-              <a:rPr lang="en-US" sz="1600" dirty="0">
+              <a:rPr lang="en-US" sz="1800" dirty="0">
                 <a:latin typeface="Times New Roman" panose="02020603050405020304" pitchFamily="18" charset="0"/>
                 <a:cs typeface="Times New Roman" panose="02020603050405020304" pitchFamily="18" charset="0"/>
               </a:rPr>
@@ -7106,14 +7106,14 @@
               </a:lnSpc>
             </a:pPr>
             <a:r>
-              <a:rPr lang="en-US" sz="1600" b="1" dirty="0">
+              <a:rPr lang="en-US" sz="1800" b="1" dirty="0">
                 <a:latin typeface="Times New Roman" panose="02020603050405020304" pitchFamily="18" charset="0"/>
                 <a:cs typeface="Times New Roman" panose="02020603050405020304" pitchFamily="18" charset="0"/>
               </a:rPr>
               <a:t>Stream: </a:t>
             </a:r>
             <a:r>
-              <a:rPr lang="en-US" sz="1600" dirty="0">
+              <a:rPr lang="en-US" sz="1800" dirty="0">
                 <a:latin typeface="Times New Roman" panose="02020603050405020304" pitchFamily="18" charset="0"/>
                 <a:cs typeface="Times New Roman" panose="02020603050405020304" pitchFamily="18" charset="0"/>
               </a:rPr>
@@ -7127,14 +7127,14 @@
               </a:lnSpc>
             </a:pPr>
             <a:r>
-              <a:rPr lang="en-US" sz="1600" b="1" dirty="0">
+              <a:rPr lang="en-US" sz="1800" b="1" dirty="0">
                 <a:latin typeface="Times New Roman" panose="02020603050405020304" pitchFamily="18" charset="0"/>
                 <a:cs typeface="Times New Roman" panose="02020603050405020304" pitchFamily="18" charset="0"/>
               </a:rPr>
               <a:t>Possession: </a:t>
             </a:r>
             <a:r>
-              <a:rPr lang="en-US" sz="1600" dirty="0">
+              <a:rPr lang="en-US" sz="1800" dirty="0">
                 <a:latin typeface="Times New Roman" panose="02020603050405020304" pitchFamily="18" charset="0"/>
                 <a:cs typeface="Times New Roman" panose="02020603050405020304" pitchFamily="18" charset="0"/>
               </a:rPr>
@@ -7148,14 +7148,14 @@
               </a:lnSpc>
             </a:pPr>
             <a:r>
-              <a:rPr lang="en-US" sz="1600" b="1" dirty="0">
+              <a:rPr lang="en-US" sz="1800" b="1" dirty="0">
                 <a:latin typeface="Times New Roman" panose="02020603050405020304" pitchFamily="18" charset="0"/>
                 <a:cs typeface="Times New Roman" panose="02020603050405020304" pitchFamily="18" charset="0"/>
               </a:rPr>
               <a:t>Content: </a:t>
             </a:r>
             <a:r>
-              <a:rPr lang="en-US" sz="1600" dirty="0">
+              <a:rPr lang="en-US" sz="1800" dirty="0">
                 <a:latin typeface="Times New Roman" panose="02020603050405020304" pitchFamily="18" charset="0"/>
                 <a:cs typeface="Times New Roman" panose="02020603050405020304" pitchFamily="18" charset="0"/>
               </a:rPr>
@@ -7169,14 +7169,14 @@
               </a:lnSpc>
             </a:pPr>
             <a:r>
-              <a:rPr lang="en-US" sz="1600" b="1" dirty="0">
+              <a:rPr lang="en-US" sz="1800" b="1" dirty="0">
                 <a:latin typeface="Times New Roman" panose="02020603050405020304" pitchFamily="18" charset="0"/>
                 <a:cs typeface="Times New Roman" panose="02020603050405020304" pitchFamily="18" charset="0"/>
               </a:rPr>
               <a:t>Death Wishes: </a:t>
             </a:r>
             <a:r>
-              <a:rPr lang="en-US" sz="1600" dirty="0">
+              <a:rPr lang="en-US" sz="1800" dirty="0">
                 <a:latin typeface="Times New Roman" panose="02020603050405020304" pitchFamily="18" charset="0"/>
                 <a:cs typeface="Times New Roman" panose="02020603050405020304" pitchFamily="18" charset="0"/>
               </a:rPr>
@@ -7262,7 +7262,7 @@
               </a:lnSpc>
             </a:pPr>
             <a:r>
-              <a:rPr lang="en-US" sz="1600" b="1" dirty="0">
+              <a:rPr lang="en-US" sz="1800" b="1" dirty="0">
                 <a:latin typeface="Times New Roman" panose="02020603050405020304" pitchFamily="18" charset="0"/>
                 <a:cs typeface="Times New Roman" panose="02020603050405020304" pitchFamily="18" charset="0"/>
               </a:rPr>
@@ -7276,7 +7276,7 @@
               </a:lnSpc>
             </a:pPr>
             <a:r>
-              <a:rPr lang="en-US" sz="1600" dirty="0">
+              <a:rPr lang="en-US" sz="1800" dirty="0">
                 <a:latin typeface="Times New Roman" panose="02020603050405020304" pitchFamily="18" charset="0"/>
                 <a:cs typeface="Times New Roman" panose="02020603050405020304" pitchFamily="18" charset="0"/>
               </a:rPr>
@@ -7290,14 +7290,14 @@
               </a:lnSpc>
             </a:pPr>
             <a:r>
-              <a:rPr lang="en-US" sz="1600" b="1" dirty="0">
+              <a:rPr lang="en-US" sz="1800" b="1" dirty="0">
                 <a:latin typeface="Times New Roman" panose="02020603050405020304" pitchFamily="18" charset="0"/>
                 <a:cs typeface="Times New Roman" panose="02020603050405020304" pitchFamily="18" charset="0"/>
               </a:rPr>
               <a:t>OPD No: </a:t>
             </a:r>
             <a:r>
-              <a:rPr lang="en-US" sz="1600" dirty="0">
+              <a:rPr lang="en-US" sz="1800" dirty="0">
                 <a:latin typeface="Times New Roman" panose="02020603050405020304" pitchFamily="18" charset="0"/>
                 <a:cs typeface="Times New Roman" panose="02020603050405020304" pitchFamily="18" charset="0"/>
               </a:rPr>
@@ -7311,14 +7311,14 @@
               </a:lnSpc>
             </a:pPr>
             <a:r>
-              <a:rPr lang="en-US" sz="1600" b="1" dirty="0">
+              <a:rPr lang="en-US" sz="1800" b="1" dirty="0">
                 <a:latin typeface="Times New Roman" panose="02020603050405020304" pitchFamily="18" charset="0"/>
                 <a:cs typeface="Times New Roman" panose="02020603050405020304" pitchFamily="18" charset="0"/>
               </a:rPr>
               <a:t>Date of Administration: </a:t>
             </a:r>
             <a:r>
-              <a:rPr lang="en-US" sz="1600" dirty="0">
+              <a:rPr lang="en-US" sz="1800" dirty="0">
                 <a:latin typeface="Times New Roman" panose="02020603050405020304" pitchFamily="18" charset="0"/>
                 <a:cs typeface="Times New Roman" panose="02020603050405020304" pitchFamily="18" charset="0"/>
               </a:rPr>
@@ -7332,14 +7332,14 @@
               </a:lnSpc>
             </a:pPr>
             <a:r>
-              <a:rPr lang="en-US" sz="1600" b="1" dirty="0">
+              <a:rPr lang="en-US" sz="1800" b="1" dirty="0">
                 <a:latin typeface="Times New Roman" panose="02020603050405020304" pitchFamily="18" charset="0"/>
                 <a:cs typeface="Times New Roman" panose="02020603050405020304" pitchFamily="18" charset="0"/>
               </a:rPr>
               <a:t>Name: </a:t>
             </a:r>
             <a:r>
-              <a:rPr lang="en-US" sz="1600" dirty="0">
+              <a:rPr lang="en-US" sz="1800" dirty="0">
                 <a:latin typeface="Times New Roman" panose="02020603050405020304" pitchFamily="18" charset="0"/>
                 <a:cs typeface="Times New Roman" panose="02020603050405020304" pitchFamily="18" charset="0"/>
               </a:rPr>
@@ -7353,14 +7353,14 @@
               </a:lnSpc>
             </a:pPr>
             <a:r>
-              <a:rPr lang="en-US" sz="1600" b="1" dirty="0">
+              <a:rPr lang="en-US" sz="1800" b="1" dirty="0">
                 <a:latin typeface="Times New Roman" panose="02020603050405020304" pitchFamily="18" charset="0"/>
                 <a:cs typeface="Times New Roman" panose="02020603050405020304" pitchFamily="18" charset="0"/>
               </a:rPr>
               <a:t>Gender: </a:t>
             </a:r>
             <a:r>
-              <a:rPr lang="en-US" sz="1600" dirty="0">
+              <a:rPr lang="en-US" sz="1800" dirty="0">
                 <a:latin typeface="Times New Roman" panose="02020603050405020304" pitchFamily="18" charset="0"/>
                 <a:cs typeface="Times New Roman" panose="02020603050405020304" pitchFamily="18" charset="0"/>
               </a:rPr>
@@ -7374,14 +7374,14 @@
               </a:lnSpc>
             </a:pPr>
             <a:r>
-              <a:rPr lang="en-US" sz="1600" b="1" dirty="0">
+              <a:rPr lang="en-US" sz="1800" b="1" dirty="0">
                 <a:latin typeface="Times New Roman" panose="02020603050405020304" pitchFamily="18" charset="0"/>
                 <a:cs typeface="Times New Roman" panose="02020603050405020304" pitchFamily="18" charset="0"/>
               </a:rPr>
               <a:t>Marital Status: </a:t>
             </a:r>
             <a:r>
-              <a:rPr lang="en-US" sz="1600" dirty="0">
+              <a:rPr lang="en-US" sz="1800" dirty="0">
                 <a:latin typeface="Times New Roman" panose="02020603050405020304" pitchFamily="18" charset="0"/>
                 <a:cs typeface="Times New Roman" panose="02020603050405020304" pitchFamily="18" charset="0"/>
               </a:rPr>
@@ -7395,14 +7395,14 @@
               </a:lnSpc>
             </a:pPr>
             <a:r>
-              <a:rPr lang="en-US" sz="1600" b="1" dirty="0">
+              <a:rPr lang="en-US" sz="1800" b="1" dirty="0">
                 <a:latin typeface="Times New Roman" panose="02020603050405020304" pitchFamily="18" charset="0"/>
                 <a:cs typeface="Times New Roman" panose="02020603050405020304" pitchFamily="18" charset="0"/>
               </a:rPr>
               <a:t>Religion: </a:t>
             </a:r>
             <a:r>
-              <a:rPr lang="en-US" sz="1600" dirty="0">
+              <a:rPr lang="en-US" sz="1800" dirty="0">
                 <a:latin typeface="Times New Roman" panose="02020603050405020304" pitchFamily="18" charset="0"/>
                 <a:cs typeface="Times New Roman" panose="02020603050405020304" pitchFamily="18" charset="0"/>
               </a:rPr>
@@ -7416,14 +7416,14 @@
               </a:lnSpc>
             </a:pPr>
             <a:r>
-              <a:rPr lang="en-US" sz="1600" b="1" dirty="0">
+              <a:rPr lang="en-US" sz="1800" b="1" dirty="0">
                 <a:latin typeface="Times New Roman" panose="02020603050405020304" pitchFamily="18" charset="0"/>
                 <a:cs typeface="Times New Roman" panose="02020603050405020304" pitchFamily="18" charset="0"/>
               </a:rPr>
               <a:t>Education: </a:t>
             </a:r>
             <a:r>
-              <a:rPr lang="en-US" sz="1600" dirty="0">
+              <a:rPr lang="en-US" sz="1800" dirty="0">
                 <a:latin typeface="Times New Roman" panose="02020603050405020304" pitchFamily="18" charset="0"/>
                 <a:cs typeface="Times New Roman" panose="02020603050405020304" pitchFamily="18" charset="0"/>
               </a:rPr>
@@ -7437,14 +7437,14 @@
               </a:lnSpc>
             </a:pPr>
             <a:r>
-              <a:rPr lang="en-US" sz="1600" b="1" dirty="0">
+              <a:rPr lang="en-US" sz="1800" b="1" dirty="0">
                 <a:latin typeface="Times New Roman" panose="02020603050405020304" pitchFamily="18" charset="0"/>
                 <a:cs typeface="Times New Roman" panose="02020603050405020304" pitchFamily="18" charset="0"/>
               </a:rPr>
               <a:t>Occupation: </a:t>
             </a:r>
             <a:r>
-              <a:rPr lang="en-US" sz="1600" dirty="0">
+              <a:rPr lang="en-US" sz="1800" dirty="0">
                 <a:latin typeface="Times New Roman" panose="02020603050405020304" pitchFamily="18" charset="0"/>
                 <a:cs typeface="Times New Roman" panose="02020603050405020304" pitchFamily="18" charset="0"/>
               </a:rPr>
@@ -7458,14 +7458,14 @@
               </a:lnSpc>
             </a:pPr>
             <a:r>
-              <a:rPr lang="en-US" sz="1600" b="1" dirty="0">
+              <a:rPr lang="en-US" sz="1800" b="1" dirty="0">
                 <a:latin typeface="Times New Roman" panose="02020603050405020304" pitchFamily="18" charset="0"/>
                 <a:cs typeface="Times New Roman" panose="02020603050405020304" pitchFamily="18" charset="0"/>
               </a:rPr>
               <a:t>Age: </a:t>
             </a:r>
             <a:r>
-              <a:rPr lang="en-US" sz="1600" dirty="0">
+              <a:rPr lang="en-US" sz="1800" dirty="0">
                 <a:latin typeface="Times New Roman" panose="02020603050405020304" pitchFamily="18" charset="0"/>
                 <a:cs typeface="Times New Roman" panose="02020603050405020304" pitchFamily="18" charset="0"/>
               </a:rPr>
@@ -7479,14 +7479,14 @@
               </a:lnSpc>
             </a:pPr>
             <a:r>
-              <a:rPr lang="en-US" sz="1600" b="1" dirty="0">
+              <a:rPr lang="en-US" sz="1800" b="1" dirty="0">
                 <a:latin typeface="Times New Roman" panose="02020603050405020304" pitchFamily="18" charset="0"/>
                 <a:cs typeface="Times New Roman" panose="02020603050405020304" pitchFamily="18" charset="0"/>
               </a:rPr>
               <a:t>Socio-Economic Status: </a:t>
             </a:r>
             <a:r>
-              <a:rPr lang="en-US" sz="1600" dirty="0">
+              <a:rPr lang="en-US" sz="1800" dirty="0">
                 <a:latin typeface="Times New Roman" panose="02020603050405020304" pitchFamily="18" charset="0"/>
                 <a:cs typeface="Times New Roman" panose="02020603050405020304" pitchFamily="18" charset="0"/>
               </a:rPr>
@@ -7500,14 +7500,14 @@
               </a:lnSpc>
             </a:pPr>
             <a:r>
-              <a:rPr lang="en-US" sz="1600" b="1" dirty="0">
+              <a:rPr lang="en-US" sz="1800" b="1" dirty="0">
                 <a:latin typeface="Times New Roman" panose="02020603050405020304" pitchFamily="18" charset="0"/>
                 <a:cs typeface="Times New Roman" panose="02020603050405020304" pitchFamily="18" charset="0"/>
               </a:rPr>
               <a:t>Address: </a:t>
             </a:r>
             <a:r>
-              <a:rPr lang="en-US" sz="1600" dirty="0">
+              <a:rPr lang="en-US" sz="1800" dirty="0">
                 <a:latin typeface="Times New Roman" panose="02020603050405020304" pitchFamily="18" charset="0"/>
                 <a:cs typeface="Times New Roman" panose="02020603050405020304" pitchFamily="18" charset="0"/>
               </a:rPr>
@@ -7593,7 +7593,7 @@
               </a:lnSpc>
             </a:pPr>
             <a:r>
-              <a:rPr lang="en-US" sz="1600" b="1" dirty="0">
+              <a:rPr lang="en-US" sz="1800" b="1" dirty="0">
                 <a:latin typeface="Times New Roman" panose="02020603050405020304" pitchFamily="18" charset="0"/>
                 <a:cs typeface="Times New Roman" panose="02020603050405020304" pitchFamily="18" charset="0"/>
               </a:rPr>
@@ -7607,7 +7607,7 @@
               </a:lnSpc>
             </a:pPr>
             <a:r>
-              <a:rPr lang="en-US" sz="1600" dirty="0">
+              <a:rPr lang="en-US" sz="1800" dirty="0">
                 <a:latin typeface="Times New Roman" panose="02020603050405020304" pitchFamily="18" charset="0"/>
                 <a:cs typeface="Times New Roman" panose="02020603050405020304" pitchFamily="18" charset="0"/>
               </a:rPr>
@@ -7621,14 +7621,14 @@
               </a:lnSpc>
             </a:pPr>
             <a:r>
-              <a:rPr lang="en-US" sz="1600" b="1" dirty="0">
+              <a:rPr lang="en-US" sz="1800" b="1" dirty="0">
                 <a:latin typeface="Times New Roman" panose="02020603050405020304" pitchFamily="18" charset="0"/>
                 <a:cs typeface="Times New Roman" panose="02020603050405020304" pitchFamily="18" charset="0"/>
               </a:rPr>
               <a:t>Subjective: </a:t>
             </a:r>
             <a:r>
-              <a:rPr lang="en-US" sz="1600" dirty="0">
+              <a:rPr lang="en-US" sz="1800" dirty="0">
                 <a:latin typeface="Times New Roman" panose="02020603050405020304" pitchFamily="18" charset="0"/>
                 <a:cs typeface="Times New Roman" panose="02020603050405020304" pitchFamily="18" charset="0"/>
               </a:rPr>
@@ -7642,14 +7642,14 @@
               </a:lnSpc>
             </a:pPr>
             <a:r>
-              <a:rPr lang="en-US" sz="1600" b="1" dirty="0">
+              <a:rPr lang="en-US" sz="1800" b="1" dirty="0">
                 <a:latin typeface="Times New Roman" panose="02020603050405020304" pitchFamily="18" charset="0"/>
                 <a:cs typeface="Times New Roman" panose="02020603050405020304" pitchFamily="18" charset="0"/>
               </a:rPr>
               <a:t>Objective: </a:t>
             </a:r>
             <a:r>
-              <a:rPr lang="en-US" sz="1600" dirty="0">
+              <a:rPr lang="en-US" sz="1800" dirty="0">
                 <a:latin typeface="Times New Roman" panose="02020603050405020304" pitchFamily="18" charset="0"/>
                 <a:cs typeface="Times New Roman" panose="02020603050405020304" pitchFamily="18" charset="0"/>
               </a:rPr>
@@ -7663,7 +7663,7 @@
               </a:lnSpc>
             </a:pPr>
             <a:r>
-              <a:rPr lang="en-US" sz="1600" dirty="0">
+              <a:rPr lang="en-US" sz="1800" dirty="0">
                 <a:latin typeface="Times New Roman" panose="02020603050405020304" pitchFamily="18" charset="0"/>
                 <a:cs typeface="Times New Roman" panose="02020603050405020304" pitchFamily="18" charset="0"/>
               </a:rPr>
@@ -7677,7 +7677,7 @@
               </a:lnSpc>
             </a:pPr>
             <a:r>
-              <a:rPr lang="en-US" sz="1600" dirty="0">
+              <a:rPr lang="en-US" sz="1800" dirty="0">
                 <a:latin typeface="Times New Roman" panose="02020603050405020304" pitchFamily="18" charset="0"/>
                 <a:cs typeface="Times New Roman" panose="02020603050405020304" pitchFamily="18" charset="0"/>
               </a:rPr>
@@ -7691,7 +7691,7 @@
               </a:lnSpc>
             </a:pPr>
             <a:r>
-              <a:rPr lang="en-US" sz="1600" b="1" dirty="0">
+              <a:rPr lang="en-US" sz="1800" b="1" dirty="0">
                 <a:latin typeface="Times New Roman" panose="02020603050405020304" pitchFamily="18" charset="0"/>
                 <a:cs typeface="Times New Roman" panose="02020603050405020304" pitchFamily="18" charset="0"/>
               </a:rPr>
@@ -7705,14 +7705,14 @@
               </a:lnSpc>
             </a:pPr>
             <a:r>
-              <a:rPr lang="en-US" sz="1600" b="1" dirty="0">
+              <a:rPr lang="en-US" sz="1800" b="1" dirty="0">
                 <a:latin typeface="Times New Roman" panose="02020603050405020304" pitchFamily="18" charset="0"/>
                 <a:cs typeface="Times New Roman" panose="02020603050405020304" pitchFamily="18" charset="0"/>
               </a:rPr>
               <a:t>Illusions: </a:t>
             </a:r>
             <a:r>
-              <a:rPr lang="en-US" sz="1600" dirty="0">
+              <a:rPr lang="en-US" sz="1800" dirty="0">
                 <a:latin typeface="Times New Roman" panose="02020603050405020304" pitchFamily="18" charset="0"/>
                 <a:cs typeface="Times New Roman" panose="02020603050405020304" pitchFamily="18" charset="0"/>
               </a:rPr>
@@ -7726,14 +7726,14 @@
               </a:lnSpc>
             </a:pPr>
             <a:r>
-              <a:rPr lang="en-US" sz="1600" b="1" dirty="0">
+              <a:rPr lang="en-US" sz="1800" b="1" dirty="0">
                 <a:latin typeface="Times New Roman" panose="02020603050405020304" pitchFamily="18" charset="0"/>
                 <a:cs typeface="Times New Roman" panose="02020603050405020304" pitchFamily="18" charset="0"/>
               </a:rPr>
               <a:t>Hallucinations: </a:t>
             </a:r>
             <a:r>
-              <a:rPr lang="en-US" sz="1600" dirty="0">
+              <a:rPr lang="en-US" sz="1800" dirty="0">
                 <a:latin typeface="Times New Roman" panose="02020603050405020304" pitchFamily="18" charset="0"/>
                 <a:cs typeface="Times New Roman" panose="02020603050405020304" pitchFamily="18" charset="0"/>
               </a:rPr>
@@ -7747,14 +7747,14 @@
               </a:lnSpc>
             </a:pPr>
             <a:r>
-              <a:rPr lang="en-US" sz="1600" b="1" dirty="0">
+              <a:rPr lang="en-US" sz="1800" b="1" dirty="0">
                 <a:latin typeface="Times New Roman" panose="02020603050405020304" pitchFamily="18" charset="0"/>
                 <a:cs typeface="Times New Roman" panose="02020603050405020304" pitchFamily="18" charset="0"/>
               </a:rPr>
               <a:t>Pseudo-Hallucinations: </a:t>
             </a:r>
             <a:r>
-              <a:rPr lang="en-US" sz="1600" dirty="0">
+              <a:rPr lang="en-US" sz="1800" dirty="0">
                 <a:latin typeface="Times New Roman" panose="02020603050405020304" pitchFamily="18" charset="0"/>
                 <a:cs typeface="Times New Roman" panose="02020603050405020304" pitchFamily="18" charset="0"/>
               </a:rPr>
@@ -7840,7 +7840,7 @@
               </a:lnSpc>
             </a:pPr>
             <a:r>
-              <a:rPr lang="en-US" sz="1600" b="1" dirty="0">
+              <a:rPr lang="en-US" sz="1800" b="1" dirty="0">
                 <a:latin typeface="Times New Roman" panose="02020603050405020304" pitchFamily="18" charset="0"/>
                 <a:cs typeface="Times New Roman" panose="02020603050405020304" pitchFamily="18" charset="0"/>
               </a:rPr>
@@ -7854,7 +7854,7 @@
               </a:lnSpc>
             </a:pPr>
             <a:r>
-              <a:rPr lang="en-US" sz="1600" dirty="0">
+              <a:rPr lang="en-US" sz="1800" dirty="0">
                 <a:latin typeface="Times New Roman" panose="02020603050405020304" pitchFamily="18" charset="0"/>
                 <a:cs typeface="Times New Roman" panose="02020603050405020304" pitchFamily="18" charset="0"/>
               </a:rPr>
@@ -7868,14 +7868,14 @@
               </a:lnSpc>
             </a:pPr>
             <a:r>
-              <a:rPr lang="en-US" sz="1600" b="1" dirty="0">
+              <a:rPr lang="en-US" sz="1800" b="1" dirty="0">
                 <a:latin typeface="Times New Roman" panose="02020603050405020304" pitchFamily="18" charset="0"/>
                 <a:cs typeface="Times New Roman" panose="02020603050405020304" pitchFamily="18" charset="0"/>
               </a:rPr>
               <a:t>Level of Consciousness: </a:t>
             </a:r>
             <a:r>
-              <a:rPr lang="en-US" sz="1600" dirty="0">
+              <a:rPr lang="en-US" sz="1800" dirty="0">
                 <a:latin typeface="Times New Roman" panose="02020603050405020304" pitchFamily="18" charset="0"/>
                 <a:cs typeface="Times New Roman" panose="02020603050405020304" pitchFamily="18" charset="0"/>
               </a:rPr>
@@ -7889,14 +7889,14 @@
               </a:lnSpc>
             </a:pPr>
             <a:r>
-              <a:rPr lang="en-US" sz="1600" b="1" dirty="0">
+              <a:rPr lang="en-US" sz="1800" b="1" dirty="0">
                 <a:latin typeface="Times New Roman" panose="02020603050405020304" pitchFamily="18" charset="0"/>
                 <a:cs typeface="Times New Roman" panose="02020603050405020304" pitchFamily="18" charset="0"/>
               </a:rPr>
               <a:t>Orientation: </a:t>
             </a:r>
             <a:r>
-              <a:rPr lang="en-US" sz="1600" dirty="0">
+              <a:rPr lang="en-US" sz="1800" dirty="0">
                 <a:latin typeface="Times New Roman" panose="02020603050405020304" pitchFamily="18" charset="0"/>
                 <a:cs typeface="Times New Roman" panose="02020603050405020304" pitchFamily="18" charset="0"/>
               </a:rPr>
@@ -7910,14 +7910,14 @@
               </a:lnSpc>
             </a:pPr>
             <a:r>
-              <a:rPr lang="en-US" sz="1600" b="1" dirty="0">
+              <a:rPr lang="en-US" sz="1800" b="1" dirty="0">
                 <a:latin typeface="Times New Roman" panose="02020603050405020304" pitchFamily="18" charset="0"/>
                 <a:cs typeface="Times New Roman" panose="02020603050405020304" pitchFamily="18" charset="0"/>
               </a:rPr>
               <a:t>Attention and Concentration: </a:t>
             </a:r>
             <a:r>
-              <a:rPr lang="en-US" sz="1600" dirty="0">
+              <a:rPr lang="en-US" sz="1800" dirty="0">
                 <a:latin typeface="Times New Roman" panose="02020603050405020304" pitchFamily="18" charset="0"/>
                 <a:cs typeface="Times New Roman" panose="02020603050405020304" pitchFamily="18" charset="0"/>
               </a:rPr>
@@ -8003,7 +8003,7 @@
               </a:lnSpc>
             </a:pPr>
             <a:r>
-              <a:rPr lang="en-US" sz="1600" b="1" dirty="0">
+              <a:rPr lang="en-US" sz="1800" b="1" dirty="0">
                 <a:latin typeface="Times New Roman" panose="02020603050405020304" pitchFamily="18" charset="0"/>
                 <a:cs typeface="Times New Roman" panose="02020603050405020304" pitchFamily="18" charset="0"/>
               </a:rPr>
@@ -8017,7 +8017,7 @@
               </a:lnSpc>
             </a:pPr>
             <a:r>
-              <a:rPr lang="en-US" sz="1600" dirty="0">
+              <a:rPr lang="en-US" sz="1800" dirty="0">
                 <a:latin typeface="Times New Roman" panose="02020603050405020304" pitchFamily="18" charset="0"/>
                 <a:cs typeface="Times New Roman" panose="02020603050405020304" pitchFamily="18" charset="0"/>
               </a:rPr>
@@ -8031,7 +8031,7 @@
               </a:lnSpc>
             </a:pPr>
             <a:r>
-              <a:rPr lang="en-US" sz="1600" dirty="0">
+              <a:rPr lang="en-US" sz="1800" dirty="0">
                 <a:latin typeface="Times New Roman" panose="02020603050405020304" pitchFamily="18" charset="0"/>
                 <a:cs typeface="Times New Roman" panose="02020603050405020304" pitchFamily="18" charset="0"/>
               </a:rPr>
@@ -8117,7 +8117,7 @@
               </a:lnSpc>
             </a:pPr>
             <a:r>
-              <a:rPr lang="en-US" sz="1600" b="1" dirty="0">
+              <a:rPr lang="en-US" sz="1800" b="1" dirty="0">
                 <a:latin typeface="Times New Roman" panose="02020603050405020304" pitchFamily="18" charset="0"/>
                 <a:cs typeface="Times New Roman" panose="02020603050405020304" pitchFamily="18" charset="0"/>
               </a:rPr>
@@ -8131,7 +8131,7 @@
               </a:lnSpc>
             </a:pPr>
             <a:r>
-              <a:rPr lang="en-US" sz="1600" dirty="0">
+              <a:rPr lang="en-US" sz="1800" dirty="0">
                 <a:latin typeface="Times New Roman" panose="02020603050405020304" pitchFamily="18" charset="0"/>
                 <a:cs typeface="Times New Roman" panose="02020603050405020304" pitchFamily="18" charset="0"/>
               </a:rPr>
@@ -8145,7 +8145,7 @@
               </a:lnSpc>
             </a:pPr>
             <a:r>
-              <a:rPr lang="en-US" sz="1600" dirty="0">
+              <a:rPr lang="en-US" sz="1800" dirty="0">
                 <a:latin typeface="Times New Roman" panose="02020603050405020304" pitchFamily="18" charset="0"/>
                 <a:cs typeface="Times New Roman" panose="02020603050405020304" pitchFamily="18" charset="0"/>
               </a:rPr>
@@ -8231,7 +8231,7 @@
               </a:lnSpc>
             </a:pPr>
             <a:r>
-              <a:rPr lang="en-US" sz="1600" b="1" dirty="0">
+              <a:rPr lang="en-US" sz="1800" b="1" dirty="0">
                 <a:latin typeface="Times New Roman" panose="02020603050405020304" pitchFamily="18" charset="0"/>
                 <a:cs typeface="Times New Roman" panose="02020603050405020304" pitchFamily="18" charset="0"/>
               </a:rPr>
@@ -8245,7 +8245,7 @@
               </a:lnSpc>
             </a:pPr>
             <a:r>
-              <a:rPr lang="en-US" sz="1600" dirty="0">
+              <a:rPr lang="en-US" sz="1800" dirty="0">
                 <a:latin typeface="Times New Roman" panose="02020603050405020304" pitchFamily="18" charset="0"/>
                 <a:cs typeface="Times New Roman" panose="02020603050405020304" pitchFamily="18" charset="0"/>
               </a:rPr>
@@ -8259,7 +8259,7 @@
               </a:lnSpc>
             </a:pPr>
             <a:r>
-              <a:rPr lang="en-US" sz="1600" dirty="0">
+              <a:rPr lang="en-US" sz="1800" dirty="0">
                 <a:latin typeface="Times New Roman" panose="02020603050405020304" pitchFamily="18" charset="0"/>
                 <a:cs typeface="Times New Roman" panose="02020603050405020304" pitchFamily="18" charset="0"/>
               </a:rPr>
@@ -8345,7 +8345,7 @@
               </a:lnSpc>
             </a:pPr>
             <a:r>
-              <a:rPr lang="en-US" sz="1600" b="1" dirty="0">
+              <a:rPr lang="en-US" sz="1800" b="1" dirty="0">
                 <a:latin typeface="Times New Roman" panose="02020603050405020304" pitchFamily="18" charset="0"/>
                 <a:cs typeface="Times New Roman" panose="02020603050405020304" pitchFamily="18" charset="0"/>
               </a:rPr>
@@ -8359,7 +8359,7 @@
               </a:lnSpc>
             </a:pPr>
             <a:r>
-              <a:rPr lang="en-US" sz="1600" dirty="0">
+              <a:rPr lang="en-US" sz="1800" dirty="0">
                 <a:latin typeface="Times New Roman" panose="02020603050405020304" pitchFamily="18" charset="0"/>
                 <a:cs typeface="Times New Roman" panose="02020603050405020304" pitchFamily="18" charset="0"/>
               </a:rPr>
@@ -8373,7 +8373,7 @@
               </a:lnSpc>
             </a:pPr>
             <a:r>
-              <a:rPr lang="en-US" sz="1600" dirty="0">
+              <a:rPr lang="en-US" sz="1800" dirty="0">
                 <a:latin typeface="Times New Roman" panose="02020603050405020304" pitchFamily="18" charset="0"/>
                 <a:cs typeface="Times New Roman" panose="02020603050405020304" pitchFamily="18" charset="0"/>
               </a:rPr>
@@ -8459,7 +8459,7 @@
               </a:lnSpc>
             </a:pPr>
             <a:r>
-              <a:rPr lang="en-US" sz="1600" b="1" dirty="0">
+              <a:rPr lang="en-US" sz="1800" b="1" dirty="0">
                 <a:latin typeface="Times New Roman" panose="02020603050405020304" pitchFamily="18" charset="0"/>
                 <a:cs typeface="Times New Roman" panose="02020603050405020304" pitchFamily="18" charset="0"/>
               </a:rPr>
@@ -8473,7 +8473,7 @@
               </a:lnSpc>
             </a:pPr>
             <a:r>
-              <a:rPr lang="en-US" sz="1600" dirty="0">
+              <a:rPr lang="en-US" sz="1800" dirty="0">
                 <a:latin typeface="Times New Roman" panose="02020603050405020304" pitchFamily="18" charset="0"/>
                 <a:cs typeface="Times New Roman" panose="02020603050405020304" pitchFamily="18" charset="0"/>
               </a:rPr>
@@ -8487,7 +8487,7 @@
               </a:lnSpc>
             </a:pPr>
             <a:r>
-              <a:rPr lang="en-US" sz="1600" dirty="0">
+              <a:rPr lang="en-US" sz="1800" dirty="0">
                 <a:latin typeface="Times New Roman" panose="02020603050405020304" pitchFamily="18" charset="0"/>
                 <a:cs typeface="Times New Roman" panose="02020603050405020304" pitchFamily="18" charset="0"/>
               </a:rPr>
@@ -8501,7 +8501,7 @@
               </a:lnSpc>
             </a:pPr>
             <a:r>
-              <a:rPr lang="en-US" sz="1600" dirty="0">
+              <a:rPr lang="en-US" sz="1800" dirty="0">
                 <a:latin typeface="Times New Roman" panose="02020603050405020304" pitchFamily="18" charset="0"/>
                 <a:cs typeface="Times New Roman" panose="02020603050405020304" pitchFamily="18" charset="0"/>
               </a:rPr>
@@ -8515,14 +8515,14 @@
               </a:lnSpc>
             </a:pPr>
             <a:r>
-              <a:rPr lang="en-US" sz="1600" b="1" dirty="0">
+              <a:rPr lang="en-US" sz="1800" b="1" dirty="0">
                 <a:latin typeface="Times New Roman" panose="02020603050405020304" pitchFamily="18" charset="0"/>
                 <a:cs typeface="Times New Roman" panose="02020603050405020304" pitchFamily="18" charset="0"/>
               </a:rPr>
               <a:t>Insight: </a:t>
             </a:r>
             <a:r>
-              <a:rPr lang="en-US" sz="1600" dirty="0">
+              <a:rPr lang="en-US" sz="1800" dirty="0">
                 <a:latin typeface="Times New Roman" panose="02020603050405020304" pitchFamily="18" charset="0"/>
                 <a:cs typeface="Times New Roman" panose="02020603050405020304" pitchFamily="18" charset="0"/>
               </a:rPr>
@@ -8608,7 +8608,7 @@
               </a:lnSpc>
             </a:pPr>
             <a:r>
-              <a:rPr lang="en-US" sz="1600" b="1" dirty="0">
+              <a:rPr lang="en-US" sz="1800" b="1" dirty="0">
                 <a:latin typeface="Times New Roman" panose="02020603050405020304" pitchFamily="18" charset="0"/>
                 <a:cs typeface="Times New Roman" panose="02020603050405020304" pitchFamily="18" charset="0"/>
               </a:rPr>
@@ -8622,7 +8622,7 @@
               </a:lnSpc>
             </a:pPr>
             <a:r>
-              <a:rPr lang="en-US" sz="1600" dirty="0">
+              <a:rPr lang="en-US" sz="1800" dirty="0">
                 <a:latin typeface="Times New Roman" panose="02020603050405020304" pitchFamily="18" charset="0"/>
                 <a:cs typeface="Times New Roman" panose="02020603050405020304" pitchFamily="18" charset="0"/>
               </a:rPr>
@@ -8638,7 +8638,7 @@
               <a:buChar char="•"/>
             </a:pPr>
             <a:r>
-              <a:rPr lang="en-US" sz="1600" dirty="0">
+              <a:rPr lang="en-US" sz="1800" dirty="0">
                 <a:latin typeface="Times New Roman" panose="02020603050405020304" pitchFamily="18" charset="0"/>
                 <a:cs typeface="Times New Roman" panose="02020603050405020304" pitchFamily="18" charset="0"/>
               </a:rPr>
@@ -8654,7 +8654,7 @@
               <a:buChar char="•"/>
             </a:pPr>
             <a:r>
-              <a:rPr lang="en-US" sz="1600" dirty="0">
+              <a:rPr lang="en-US" sz="1800" dirty="0">
                 <a:latin typeface="Times New Roman" panose="02020603050405020304" pitchFamily="18" charset="0"/>
                 <a:cs typeface="Times New Roman" panose="02020603050405020304" pitchFamily="18" charset="0"/>
               </a:rPr>
@@ -8670,7 +8670,7 @@
               <a:buChar char="•"/>
             </a:pPr>
             <a:r>
-              <a:rPr lang="en-US" sz="1600" dirty="0">
+              <a:rPr lang="en-US" sz="1800" dirty="0">
                 <a:latin typeface="Times New Roman" panose="02020603050405020304" pitchFamily="18" charset="0"/>
                 <a:cs typeface="Times New Roman" panose="02020603050405020304" pitchFamily="18" charset="0"/>
               </a:rPr>
@@ -8756,7 +8756,7 @@
               </a:lnSpc>
             </a:pPr>
             <a:r>
-              <a:rPr lang="en-US" sz="1600" b="1" dirty="0">
+              <a:rPr lang="en-US" sz="1800" b="1" dirty="0">
                 <a:latin typeface="Times New Roman" panose="02020603050405020304" pitchFamily="18" charset="0"/>
                 <a:cs typeface="Times New Roman" panose="02020603050405020304" pitchFamily="18" charset="0"/>
               </a:rPr>
@@ -8770,7 +8770,7 @@
               </a:lnSpc>
             </a:pPr>
             <a:r>
-              <a:rPr lang="en-US" sz="1600" b="1" dirty="0">
+              <a:rPr lang="en-US" sz="1800" b="1" dirty="0">
                 <a:latin typeface="Times New Roman" panose="02020603050405020304" pitchFamily="18" charset="0"/>
                 <a:cs typeface="Times New Roman" panose="02020603050405020304" pitchFamily="18" charset="0"/>
               </a:rPr>
@@ -8784,7 +8784,7 @@
               </a:lnSpc>
             </a:pPr>
             <a:r>
-              <a:rPr lang="en-US" sz="1600" dirty="0">
+              <a:rPr lang="en-US" sz="1800" dirty="0">
                 <a:latin typeface="Times New Roman" panose="02020603050405020304" pitchFamily="18" charset="0"/>
                 <a:cs typeface="Times New Roman" panose="02020603050405020304" pitchFamily="18" charset="0"/>
               </a:rPr>
@@ -8798,7 +8798,7 @@
               </a:lnSpc>
             </a:pPr>
             <a:r>
-              <a:rPr lang="en-US" sz="1600" dirty="0">
+              <a:rPr lang="en-US" sz="1800" dirty="0">
                 <a:latin typeface="Times New Roman" panose="02020603050405020304" pitchFamily="18" charset="0"/>
                 <a:cs typeface="Times New Roman" panose="02020603050405020304" pitchFamily="18" charset="0"/>
               </a:rPr>
@@ -8884,7 +8884,7 @@
               </a:lnSpc>
             </a:pPr>
             <a:r>
-              <a:rPr lang="en-US" sz="1600" b="1" dirty="0">
+              <a:rPr lang="en-US" sz="1800" b="1" dirty="0">
                 <a:latin typeface="Times New Roman" panose="02020603050405020304" pitchFamily="18" charset="0"/>
                 <a:cs typeface="Times New Roman" panose="02020603050405020304" pitchFamily="18" charset="0"/>
               </a:rPr>
@@ -8898,7 +8898,7 @@
               </a:lnSpc>
             </a:pPr>
             <a:r>
-              <a:rPr lang="en-US" sz="1600" dirty="0">
+              <a:rPr lang="en-US" sz="1800" dirty="0">
                 <a:latin typeface="Times New Roman" panose="02020603050405020304" pitchFamily="18" charset="0"/>
                 <a:cs typeface="Times New Roman" panose="02020603050405020304" pitchFamily="18" charset="0"/>
               </a:rPr>
@@ -8912,7 +8912,7 @@
               </a:lnSpc>
             </a:pPr>
             <a:r>
-              <a:rPr lang="en-US" sz="1600" dirty="0">
+              <a:rPr lang="en-US" sz="1800" dirty="0">
                 <a:latin typeface="Times New Roman" panose="02020603050405020304" pitchFamily="18" charset="0"/>
                 <a:cs typeface="Times New Roman" panose="02020603050405020304" pitchFamily="18" charset="0"/>
               </a:rPr>
@@ -8998,7 +8998,7 @@
               </a:lnSpc>
             </a:pPr>
             <a:r>
-              <a:rPr lang="en-US" sz="1600" b="1" dirty="0">
+              <a:rPr lang="en-US" sz="1800" b="1" dirty="0">
                 <a:latin typeface="Times New Roman" panose="02020603050405020304" pitchFamily="18" charset="0"/>
                 <a:cs typeface="Times New Roman" panose="02020603050405020304" pitchFamily="18" charset="0"/>
               </a:rPr>
@@ -9012,7 +9012,7 @@
               </a:lnSpc>
             </a:pPr>
             <a:r>
-              <a:rPr lang="en-US" sz="1600" dirty="0">
+              <a:rPr lang="en-US" sz="1800" dirty="0">
                 <a:latin typeface="Times New Roman" panose="02020603050405020304" pitchFamily="18" charset="0"/>
                 <a:cs typeface="Times New Roman" panose="02020603050405020304" pitchFamily="18" charset="0"/>
               </a:rPr>
@@ -9026,14 +9026,14 @@
               </a:lnSpc>
             </a:pPr>
             <a:r>
-              <a:rPr lang="en-US" sz="1600" b="1" dirty="0">
+              <a:rPr lang="en-US" sz="1800" b="1" dirty="0">
                 <a:latin typeface="Times New Roman" panose="02020603050405020304" pitchFamily="18" charset="0"/>
                 <a:cs typeface="Times New Roman" panose="02020603050405020304" pitchFamily="18" charset="0"/>
               </a:rPr>
               <a:t>Name: </a:t>
             </a:r>
             <a:r>
-              <a:rPr lang="en-US" sz="1600" dirty="0">
+              <a:rPr lang="en-US" sz="1800" dirty="0">
                 <a:latin typeface="Times New Roman" panose="02020603050405020304" pitchFamily="18" charset="0"/>
                 <a:cs typeface="Times New Roman" panose="02020603050405020304" pitchFamily="18" charset="0"/>
               </a:rPr>
@@ -9047,14 +9047,14 @@
               </a:lnSpc>
             </a:pPr>
             <a:r>
-              <a:rPr lang="en-US" sz="1600" b="1" dirty="0">
+              <a:rPr lang="en-US" sz="1800" b="1" dirty="0">
                 <a:latin typeface="Times New Roman" panose="02020603050405020304" pitchFamily="18" charset="0"/>
                 <a:cs typeface="Times New Roman" panose="02020603050405020304" pitchFamily="18" charset="0"/>
               </a:rPr>
               <a:t>Relationship: </a:t>
             </a:r>
             <a:r>
-              <a:rPr lang="en-US" sz="1600" dirty="0">
+              <a:rPr lang="en-US" sz="1800" dirty="0">
                 <a:latin typeface="Times New Roman" panose="02020603050405020304" pitchFamily="18" charset="0"/>
                 <a:cs typeface="Times New Roman" panose="02020603050405020304" pitchFamily="18" charset="0"/>
               </a:rPr>
@@ -9068,14 +9068,14 @@
               </a:lnSpc>
             </a:pPr>
             <a:r>
-              <a:rPr lang="en-US" sz="1600" b="1" dirty="0">
+              <a:rPr lang="en-US" sz="1800" b="1" dirty="0">
                 <a:latin typeface="Times New Roman" panose="02020603050405020304" pitchFamily="18" charset="0"/>
                 <a:cs typeface="Times New Roman" panose="02020603050405020304" pitchFamily="18" charset="0"/>
               </a:rPr>
               <a:t>Duration of Acquaintance: </a:t>
             </a:r>
             <a:r>
-              <a:rPr lang="en-US" sz="1600" dirty="0">
+              <a:rPr lang="en-US" sz="1800" dirty="0">
                 <a:latin typeface="Times New Roman" panose="02020603050405020304" pitchFamily="18" charset="0"/>
                 <a:cs typeface="Times New Roman" panose="02020603050405020304" pitchFamily="18" charset="0"/>
               </a:rPr>
@@ -9089,7 +9089,7 @@
               </a:lnSpc>
             </a:pPr>
             <a:r>
-              <a:rPr lang="en-US" sz="1600" dirty="0">
+              <a:rPr lang="en-US" sz="1800" dirty="0">
                 <a:latin typeface="Times New Roman" panose="02020603050405020304" pitchFamily="18" charset="0"/>
                 <a:cs typeface="Times New Roman" panose="02020603050405020304" pitchFamily="18" charset="0"/>
               </a:rPr>
@@ -9103,14 +9103,14 @@
               </a:lnSpc>
             </a:pPr>
             <a:r>
-              <a:rPr lang="en-US" sz="1600" b="1" dirty="0">
+              <a:rPr lang="en-US" sz="1800" b="1" dirty="0">
                 <a:latin typeface="Times New Roman" panose="02020603050405020304" pitchFamily="18" charset="0"/>
                 <a:cs typeface="Times New Roman" panose="02020603050405020304" pitchFamily="18" charset="0"/>
               </a:rPr>
               <a:t>Reliability and Adequacy: </a:t>
             </a:r>
             <a:r>
-              <a:rPr lang="en-US" sz="1600" dirty="0">
+              <a:rPr lang="en-US" sz="1800" dirty="0">
                 <a:latin typeface="Times New Roman" panose="02020603050405020304" pitchFamily="18" charset="0"/>
                 <a:cs typeface="Times New Roman" panose="02020603050405020304" pitchFamily="18" charset="0"/>
               </a:rPr>
@@ -9196,7 +9196,7 @@
               </a:lnSpc>
             </a:pPr>
             <a:r>
-              <a:rPr lang="en-US" sz="1600" b="1" dirty="0">
+              <a:rPr lang="en-US" sz="1800" b="1" dirty="0">
                 <a:latin typeface="Times New Roman" panose="02020603050405020304" pitchFamily="18" charset="0"/>
                 <a:cs typeface="Times New Roman" panose="02020603050405020304" pitchFamily="18" charset="0"/>
               </a:rPr>
@@ -9210,7 +9210,7 @@
               </a:lnSpc>
             </a:pPr>
             <a:r>
-              <a:rPr lang="en-US" sz="1600" dirty="0">
+              <a:rPr lang="en-US" sz="1800" dirty="0">
                 <a:latin typeface="Times New Roman" panose="02020603050405020304" pitchFamily="18" charset="0"/>
                 <a:cs typeface="Times New Roman" panose="02020603050405020304" pitchFamily="18" charset="0"/>
               </a:rPr>
@@ -9224,7 +9224,7 @@
               </a:lnSpc>
             </a:pPr>
             <a:r>
-              <a:rPr lang="en-US" sz="1600" dirty="0">
+              <a:rPr lang="en-US" sz="1800" dirty="0">
                 <a:latin typeface="Times New Roman" panose="02020603050405020304" pitchFamily="18" charset="0"/>
                 <a:cs typeface="Times New Roman" panose="02020603050405020304" pitchFamily="18" charset="0"/>
               </a:rPr>
@@ -9310,7 +9310,7 @@
               </a:lnSpc>
             </a:pPr>
             <a:r>
-              <a:rPr lang="en-US" sz="1600" b="1" dirty="0">
+              <a:rPr lang="en-US" sz="1800" b="1" dirty="0">
                 <a:latin typeface="Times New Roman" panose="02020603050405020304" pitchFamily="18" charset="0"/>
                 <a:cs typeface="Times New Roman" panose="02020603050405020304" pitchFamily="18" charset="0"/>
               </a:rPr>
@@ -9324,7 +9324,7 @@
               </a:lnSpc>
             </a:pPr>
             <a:r>
-              <a:rPr lang="en-US" sz="1600" dirty="0">
+              <a:rPr lang="en-US" sz="1800" dirty="0">
                 <a:latin typeface="Times New Roman" panose="02020603050405020304" pitchFamily="18" charset="0"/>
                 <a:cs typeface="Times New Roman" panose="02020603050405020304" pitchFamily="18" charset="0"/>
               </a:rPr>
@@ -9338,7 +9338,7 @@
               </a:lnSpc>
             </a:pPr>
             <a:r>
-              <a:rPr lang="en-US" sz="1600" dirty="0">
+              <a:rPr lang="en-US" sz="1800" dirty="0">
                 <a:latin typeface="Times New Roman" panose="02020603050405020304" pitchFamily="18" charset="0"/>
                 <a:cs typeface="Times New Roman" panose="02020603050405020304" pitchFamily="18" charset="0"/>
               </a:rPr>
@@ -9424,7 +9424,7 @@
               </a:lnSpc>
             </a:pPr>
             <a:r>
-              <a:rPr lang="en-US" sz="1600" b="1" dirty="0">
+              <a:rPr lang="en-US" sz="1800" b="1" dirty="0">
                 <a:latin typeface="Times New Roman" panose="02020603050405020304" pitchFamily="18" charset="0"/>
                 <a:cs typeface="Times New Roman" panose="02020603050405020304" pitchFamily="18" charset="0"/>
               </a:rPr>
@@ -9438,7 +9438,7 @@
               </a:lnSpc>
             </a:pPr>
             <a:r>
-              <a:rPr lang="en-US" sz="1600" dirty="0">
+              <a:rPr lang="en-US" sz="1800" dirty="0">
                 <a:latin typeface="Times New Roman" panose="02020603050405020304" pitchFamily="18" charset="0"/>
                 <a:cs typeface="Times New Roman" panose="02020603050405020304" pitchFamily="18" charset="0"/>
               </a:rPr>
@@ -9452,14 +9452,14 @@
               </a:lnSpc>
             </a:pPr>
             <a:r>
-              <a:rPr lang="en-US" sz="1600" b="1" dirty="0">
+              <a:rPr lang="en-US" sz="1800" b="1" dirty="0">
                 <a:latin typeface="Times New Roman" panose="02020603050405020304" pitchFamily="18" charset="0"/>
                 <a:cs typeface="Times New Roman" panose="02020603050405020304" pitchFamily="18" charset="0"/>
               </a:rPr>
               <a:t>F42.2 — </a:t>
             </a:r>
             <a:r>
-              <a:rPr lang="en-US" sz="1600" dirty="0">
+              <a:rPr lang="en-US" sz="1800" dirty="0">
                 <a:latin typeface="Times New Roman" panose="02020603050405020304" pitchFamily="18" charset="0"/>
                 <a:cs typeface="Times New Roman" panose="02020603050405020304" pitchFamily="18" charset="0"/>
               </a:rPr>
@@ -9473,7 +9473,7 @@
               </a:lnSpc>
             </a:pPr>
             <a:r>
-              <a:rPr lang="en-US" sz="1600" dirty="0">
+              <a:rPr lang="en-US" sz="1800" dirty="0">
                 <a:latin typeface="Times New Roman" panose="02020603050405020304" pitchFamily="18" charset="0"/>
                 <a:cs typeface="Times New Roman" panose="02020603050405020304" pitchFamily="18" charset="0"/>
               </a:rPr>
@@ -9487,7 +9487,7 @@
               </a:lnSpc>
             </a:pPr>
             <a:r>
-              <a:rPr lang="en-US" sz="1600" b="1" dirty="0">
+              <a:rPr lang="en-US" sz="1800" b="1" dirty="0">
                 <a:latin typeface="Times New Roman" panose="02020603050405020304" pitchFamily="18" charset="0"/>
                 <a:cs typeface="Times New Roman" panose="02020603050405020304" pitchFamily="18" charset="0"/>
               </a:rPr>
@@ -9503,7 +9503,7 @@
               <a:buChar char="•"/>
             </a:pPr>
             <a:r>
-              <a:rPr lang="en-US" sz="1600" dirty="0">
+              <a:rPr lang="en-US" sz="1800" dirty="0">
                 <a:latin typeface="Times New Roman" panose="02020603050405020304" pitchFamily="18" charset="0"/>
                 <a:cs typeface="Times New Roman" panose="02020603050405020304" pitchFamily="18" charset="0"/>
               </a:rPr>
@@ -9519,7 +9519,7 @@
               <a:buChar char="•"/>
             </a:pPr>
             <a:r>
-              <a:rPr lang="en-US" sz="1600" dirty="0">
+              <a:rPr lang="en-US" sz="1800" dirty="0">
                 <a:latin typeface="Times New Roman" panose="02020603050405020304" pitchFamily="18" charset="0"/>
                 <a:cs typeface="Times New Roman" panose="02020603050405020304" pitchFamily="18" charset="0"/>
               </a:rPr>
@@ -9535,7 +9535,7 @@
               <a:buChar char="•"/>
             </a:pPr>
             <a:r>
-              <a:rPr lang="en-US" sz="1600" dirty="0">
+              <a:rPr lang="en-US" sz="1800" dirty="0">
                 <a:latin typeface="Times New Roman" panose="02020603050405020304" pitchFamily="18" charset="0"/>
                 <a:cs typeface="Times New Roman" panose="02020603050405020304" pitchFamily="18" charset="0"/>
               </a:rPr>
@@ -9551,7 +9551,7 @@
               <a:buChar char="•"/>
             </a:pPr>
             <a:r>
-              <a:rPr lang="en-US" sz="1600" dirty="0">
+              <a:rPr lang="en-US" sz="1800" dirty="0">
                 <a:latin typeface="Times New Roman" panose="02020603050405020304" pitchFamily="18" charset="0"/>
                 <a:cs typeface="Times New Roman" panose="02020603050405020304" pitchFamily="18" charset="0"/>
               </a:rPr>
@@ -9637,7 +9637,7 @@
               </a:lnSpc>
             </a:pPr>
             <a:r>
-              <a:rPr lang="en-US" sz="1600" b="1" dirty="0">
+              <a:rPr lang="en-US" sz="1800" b="1" dirty="0">
                 <a:latin typeface="Times New Roman" panose="02020603050405020304" pitchFamily="18" charset="0"/>
                 <a:cs typeface="Times New Roman" panose="02020603050405020304" pitchFamily="18" charset="0"/>
               </a:rPr>
@@ -9651,7 +9651,7 @@
               </a:lnSpc>
             </a:pPr>
             <a:r>
-              <a:rPr lang="en-US" sz="1600" dirty="0">
+              <a:rPr lang="en-US" sz="1800" dirty="0">
                 <a:latin typeface="Times New Roman" panose="02020603050405020304" pitchFamily="18" charset="0"/>
                 <a:cs typeface="Times New Roman" panose="02020603050405020304" pitchFamily="18" charset="0"/>
               </a:rPr>
@@ -9665,7 +9665,7 @@
               </a:lnSpc>
             </a:pPr>
             <a:r>
-              <a:rPr lang="en-US" sz="1600" dirty="0">
+              <a:rPr lang="en-US" sz="1800" dirty="0">
                 <a:latin typeface="Times New Roman" panose="02020603050405020304" pitchFamily="18" charset="0"/>
                 <a:cs typeface="Times New Roman" panose="02020603050405020304" pitchFamily="18" charset="0"/>
               </a:rPr>
@@ -9751,7 +9751,7 @@
               </a:lnSpc>
             </a:pPr>
             <a:r>
-              <a:rPr lang="en-US" sz="1600" b="1" dirty="0">
+              <a:rPr lang="en-US" sz="1800" b="1" dirty="0">
                 <a:latin typeface="Times New Roman" panose="02020603050405020304" pitchFamily="18" charset="0"/>
                 <a:cs typeface="Times New Roman" panose="02020603050405020304" pitchFamily="18" charset="0"/>
               </a:rPr>
@@ -9765,7 +9765,7 @@
               </a:lnSpc>
             </a:pPr>
             <a:r>
-              <a:rPr lang="en-US" sz="1600" dirty="0">
+              <a:rPr lang="en-US" sz="1800" dirty="0">
                 <a:latin typeface="Times New Roman" panose="02020603050405020304" pitchFamily="18" charset="0"/>
                 <a:cs typeface="Times New Roman" panose="02020603050405020304" pitchFamily="18" charset="0"/>
               </a:rPr>
@@ -9779,7 +9779,7 @@
               </a:lnSpc>
             </a:pPr>
             <a:r>
-              <a:rPr lang="en-US" sz="1600" dirty="0">
+              <a:rPr lang="en-US" sz="1800" dirty="0">
                 <a:latin typeface="Times New Roman" panose="02020603050405020304" pitchFamily="18" charset="0"/>
                 <a:cs typeface="Times New Roman" panose="02020603050405020304" pitchFamily="18" charset="0"/>
               </a:rPr>
@@ -9865,7 +9865,7 @@
               </a:lnSpc>
             </a:pPr>
             <a:r>
-              <a:rPr lang="en-US" sz="1600" b="1" dirty="0">
+              <a:rPr lang="en-US" sz="1800" b="1" dirty="0">
                 <a:latin typeface="Times New Roman" panose="02020603050405020304" pitchFamily="18" charset="0"/>
                 <a:cs typeface="Times New Roman" panose="02020603050405020304" pitchFamily="18" charset="0"/>
               </a:rPr>
@@ -9879,7 +9879,7 @@
               </a:lnSpc>
             </a:pPr>
             <a:r>
-              <a:rPr lang="en-US" sz="1600" dirty="0">
+              <a:rPr lang="en-US" sz="1800" dirty="0">
                 <a:latin typeface="Times New Roman" panose="02020603050405020304" pitchFamily="18" charset="0"/>
                 <a:cs typeface="Times New Roman" panose="02020603050405020304" pitchFamily="18" charset="0"/>
               </a:rPr>
@@ -9893,7 +9893,7 @@
               </a:lnSpc>
             </a:pPr>
             <a:r>
-              <a:rPr lang="en-US" sz="1600" dirty="0">
+              <a:rPr lang="en-US" sz="1800" dirty="0">
                 <a:latin typeface="Times New Roman" panose="02020603050405020304" pitchFamily="18" charset="0"/>
                 <a:cs typeface="Times New Roman" panose="02020603050405020304" pitchFamily="18" charset="0"/>
               </a:rPr>
@@ -9979,7 +9979,7 @@
               </a:lnSpc>
             </a:pPr>
             <a:r>
-              <a:rPr lang="en-US" sz="1600" b="1" dirty="0">
+              <a:rPr lang="en-US" sz="1800" b="1" dirty="0">
                 <a:latin typeface="Times New Roman" panose="02020603050405020304" pitchFamily="18" charset="0"/>
                 <a:cs typeface="Times New Roman" panose="02020603050405020304" pitchFamily="18" charset="0"/>
               </a:rPr>
@@ -9993,7 +9993,7 @@
               </a:lnSpc>
             </a:pPr>
             <a:r>
-              <a:rPr lang="en-US" sz="1600" dirty="0">
+              <a:rPr lang="en-US" sz="1800" dirty="0">
                 <a:latin typeface="Times New Roman" panose="02020603050405020304" pitchFamily="18" charset="0"/>
                 <a:cs typeface="Times New Roman" panose="02020603050405020304" pitchFamily="18" charset="0"/>
               </a:rPr>
@@ -10007,7 +10007,7 @@
               </a:lnSpc>
             </a:pPr>
             <a:r>
-              <a:rPr lang="en-US" sz="1600" b="1" dirty="0">
+              <a:rPr lang="en-US" sz="1800" b="1" dirty="0">
                 <a:latin typeface="Times New Roman" panose="02020603050405020304" pitchFamily="18" charset="0"/>
                 <a:cs typeface="Times New Roman" panose="02020603050405020304" pitchFamily="18" charset="0"/>
               </a:rPr>
@@ -10023,7 +10023,7 @@
               <a:buChar char="•"/>
             </a:pPr>
             <a:r>
-              <a:rPr lang="en-US" sz="1600" dirty="0">
+              <a:rPr lang="en-US" sz="1800" dirty="0">
                 <a:latin typeface="Times New Roman" panose="02020603050405020304" pitchFamily="18" charset="0"/>
                 <a:cs typeface="Times New Roman" panose="02020603050405020304" pitchFamily="18" charset="0"/>
               </a:rPr>
@@ -10039,7 +10039,7 @@
               <a:buChar char="•"/>
             </a:pPr>
             <a:r>
-              <a:rPr lang="en-US" sz="1600" dirty="0">
+              <a:rPr lang="en-US" sz="1800" dirty="0">
                 <a:latin typeface="Times New Roman" panose="02020603050405020304" pitchFamily="18" charset="0"/>
                 <a:cs typeface="Times New Roman" panose="02020603050405020304" pitchFamily="18" charset="0"/>
               </a:rPr>
@@ -10055,7 +10055,7 @@
               <a:buChar char="•"/>
             </a:pPr>
             <a:r>
-              <a:rPr lang="en-US" sz="1600" dirty="0">
+              <a:rPr lang="en-US" sz="1800" dirty="0">
                 <a:latin typeface="Times New Roman" panose="02020603050405020304" pitchFamily="18" charset="0"/>
                 <a:cs typeface="Times New Roman" panose="02020603050405020304" pitchFamily="18" charset="0"/>
               </a:rPr>
@@ -10071,7 +10071,7 @@
               <a:buChar char="•"/>
             </a:pPr>
             <a:r>
-              <a:rPr lang="en-US" sz="1600" dirty="0">
+              <a:rPr lang="en-US" sz="1800" dirty="0">
                 <a:latin typeface="Times New Roman" panose="02020603050405020304" pitchFamily="18" charset="0"/>
                 <a:cs typeface="Times New Roman" panose="02020603050405020304" pitchFamily="18" charset="0"/>
               </a:rPr>
@@ -10085,7 +10085,7 @@
               </a:lnSpc>
             </a:pPr>
             <a:r>
-              <a:rPr lang="en-US" sz="1600" b="1" dirty="0">
+              <a:rPr lang="en-US" sz="1800" b="1" dirty="0">
                 <a:latin typeface="Times New Roman" panose="02020603050405020304" pitchFamily="18" charset="0"/>
                 <a:cs typeface="Times New Roman" panose="02020603050405020304" pitchFamily="18" charset="0"/>
               </a:rPr>
@@ -10101,7 +10101,7 @@
               <a:buChar char="•"/>
             </a:pPr>
             <a:r>
-              <a:rPr lang="en-US" sz="1600" dirty="0">
+              <a:rPr lang="en-US" sz="1800" dirty="0">
                 <a:latin typeface="Times New Roman" panose="02020603050405020304" pitchFamily="18" charset="0"/>
                 <a:cs typeface="Times New Roman" panose="02020603050405020304" pitchFamily="18" charset="0"/>
               </a:rPr>
@@ -10117,7 +10117,7 @@
               <a:buChar char="•"/>
             </a:pPr>
             <a:r>
-              <a:rPr lang="en-US" sz="1600" dirty="0">
+              <a:rPr lang="en-US" sz="1800" dirty="0">
                 <a:latin typeface="Times New Roman" panose="02020603050405020304" pitchFamily="18" charset="0"/>
                 <a:cs typeface="Times New Roman" panose="02020603050405020304" pitchFamily="18" charset="0"/>
               </a:rPr>
@@ -10133,7 +10133,7 @@
               <a:buChar char="•"/>
             </a:pPr>
             <a:r>
-              <a:rPr lang="en-US" sz="1600" dirty="0">
+              <a:rPr lang="en-US" sz="1800" dirty="0">
                 <a:latin typeface="Times New Roman" panose="02020603050405020304" pitchFamily="18" charset="0"/>
                 <a:cs typeface="Times New Roman" panose="02020603050405020304" pitchFamily="18" charset="0"/>
               </a:rPr>
@@ -10219,7 +10219,7 @@
               </a:lnSpc>
             </a:pPr>
             <a:r>
-              <a:rPr lang="en-US" sz="1600" b="1" dirty="0">
+              <a:rPr lang="en-US" sz="1800" b="1" dirty="0">
                 <a:latin typeface="Times New Roman" panose="02020603050405020304" pitchFamily="18" charset="0"/>
                 <a:cs typeface="Times New Roman" panose="02020603050405020304" pitchFamily="18" charset="0"/>
               </a:rPr>
@@ -10233,7 +10233,7 @@
               </a:lnSpc>
             </a:pPr>
             <a:r>
-              <a:rPr lang="en-US" sz="1600" dirty="0">
+              <a:rPr lang="en-US" sz="1800" dirty="0">
                 <a:latin typeface="Times New Roman" panose="02020603050405020304" pitchFamily="18" charset="0"/>
                 <a:cs typeface="Times New Roman" panose="02020603050405020304" pitchFamily="18" charset="0"/>
               </a:rPr>
@@ -10247,7 +10247,7 @@
               </a:lnSpc>
             </a:pPr>
             <a:r>
-              <a:rPr lang="en-US" sz="1600" b="1" dirty="0">
+              <a:rPr lang="en-US" sz="1800" b="1" dirty="0">
                 <a:latin typeface="Times New Roman" panose="02020603050405020304" pitchFamily="18" charset="0"/>
                 <a:cs typeface="Times New Roman" panose="02020603050405020304" pitchFamily="18" charset="0"/>
               </a:rPr>
@@ -10263,7 +10263,7 @@
               <a:buChar char="•"/>
             </a:pPr>
             <a:r>
-              <a:rPr lang="en-US" sz="1600" dirty="0">
+              <a:rPr lang="en-US" sz="1800" dirty="0">
                 <a:latin typeface="Times New Roman" panose="02020603050405020304" pitchFamily="18" charset="0"/>
                 <a:cs typeface="Times New Roman" panose="02020603050405020304" pitchFamily="18" charset="0"/>
               </a:rPr>
@@ -10279,7 +10279,7 @@
               <a:buChar char="•"/>
             </a:pPr>
             <a:r>
-              <a:rPr lang="en-US" sz="1600" dirty="0">
+              <a:rPr lang="en-US" sz="1800" dirty="0">
                 <a:latin typeface="Times New Roman" panose="02020603050405020304" pitchFamily="18" charset="0"/>
                 <a:cs typeface="Times New Roman" panose="02020603050405020304" pitchFamily="18" charset="0"/>
               </a:rPr>
@@ -10295,7 +10295,7 @@
               <a:buChar char="•"/>
             </a:pPr>
             <a:r>
-              <a:rPr lang="en-US" sz="1600" dirty="0">
+              <a:rPr lang="en-US" sz="1800" dirty="0">
                 <a:latin typeface="Times New Roman" panose="02020603050405020304" pitchFamily="18" charset="0"/>
                 <a:cs typeface="Times New Roman" panose="02020603050405020304" pitchFamily="18" charset="0"/>
               </a:rPr>
@@ -10311,7 +10311,7 @@
               <a:buChar char="•"/>
             </a:pPr>
             <a:r>
-              <a:rPr lang="en-US" sz="1600" dirty="0">
+              <a:rPr lang="en-US" sz="1800" dirty="0">
                 <a:latin typeface="Times New Roman" panose="02020603050405020304" pitchFamily="18" charset="0"/>
                 <a:cs typeface="Times New Roman" panose="02020603050405020304" pitchFamily="18" charset="0"/>
               </a:rPr>
@@ -10327,7 +10327,7 @@
               <a:buChar char="•"/>
             </a:pPr>
             <a:r>
-              <a:rPr lang="en-US" sz="1600" dirty="0">
+              <a:rPr lang="en-US" sz="1800" dirty="0">
                 <a:latin typeface="Times New Roman" panose="02020603050405020304" pitchFamily="18" charset="0"/>
                 <a:cs typeface="Times New Roman" panose="02020603050405020304" pitchFamily="18" charset="0"/>
               </a:rPr>
@@ -10343,7 +10343,7 @@
               <a:buChar char="•"/>
             </a:pPr>
             <a:r>
-              <a:rPr lang="en-US" sz="1600" dirty="0">
+              <a:rPr lang="en-US" sz="1800" dirty="0">
                 <a:latin typeface="Times New Roman" panose="02020603050405020304" pitchFamily="18" charset="0"/>
                 <a:cs typeface="Times New Roman" panose="02020603050405020304" pitchFamily="18" charset="0"/>
               </a:rPr>
@@ -10357,7 +10357,7 @@
               </a:lnSpc>
             </a:pPr>
             <a:r>
-              <a:rPr lang="en-US" sz="1600" b="1" dirty="0">
+              <a:rPr lang="en-US" sz="1800" b="1" dirty="0">
                 <a:latin typeface="Times New Roman" panose="02020603050405020304" pitchFamily="18" charset="0"/>
                 <a:cs typeface="Times New Roman" panose="02020603050405020304" pitchFamily="18" charset="0"/>
               </a:rPr>
@@ -10373,7 +10373,7 @@
               <a:buChar char="•"/>
             </a:pPr>
             <a:r>
-              <a:rPr lang="en-US" sz="1600" dirty="0">
+              <a:rPr lang="en-US" sz="1800" dirty="0">
                 <a:latin typeface="Times New Roman" panose="02020603050405020304" pitchFamily="18" charset="0"/>
                 <a:cs typeface="Times New Roman" panose="02020603050405020304" pitchFamily="18" charset="0"/>
               </a:rPr>
@@ -10389,7 +10389,7 @@
               <a:buChar char="•"/>
             </a:pPr>
             <a:r>
-              <a:rPr lang="en-US" sz="1600" dirty="0">
+              <a:rPr lang="en-US" sz="1800" dirty="0">
                 <a:latin typeface="Times New Roman" panose="02020603050405020304" pitchFamily="18" charset="0"/>
                 <a:cs typeface="Times New Roman" panose="02020603050405020304" pitchFamily="18" charset="0"/>
               </a:rPr>
@@ -10405,7 +10405,7 @@
               <a:buChar char="•"/>
             </a:pPr>
             <a:r>
-              <a:rPr lang="en-US" sz="1600" dirty="0">
+              <a:rPr lang="en-US" sz="1800" dirty="0">
                 <a:latin typeface="Times New Roman" panose="02020603050405020304" pitchFamily="18" charset="0"/>
                 <a:cs typeface="Times New Roman" panose="02020603050405020304" pitchFamily="18" charset="0"/>
               </a:rPr>
@@ -10491,7 +10491,7 @@
               </a:lnSpc>
             </a:pPr>
             <a:r>
-              <a:rPr lang="en-US" sz="1600" b="1" dirty="0">
+              <a:rPr lang="en-US" sz="1800" b="1" dirty="0">
                 <a:latin typeface="Times New Roman" panose="02020603050405020304" pitchFamily="18" charset="0"/>
                 <a:cs typeface="Times New Roman" panose="02020603050405020304" pitchFamily="18" charset="0"/>
               </a:rPr>
@@ -10505,7 +10505,7 @@
               </a:lnSpc>
             </a:pPr>
             <a:r>
-              <a:rPr lang="en-US" sz="1600" dirty="0">
+              <a:rPr lang="en-US" sz="1800" dirty="0">
                 <a:latin typeface="Times New Roman" panose="02020603050405020304" pitchFamily="18" charset="0"/>
                 <a:cs typeface="Times New Roman" panose="02020603050405020304" pitchFamily="18" charset="0"/>
               </a:rPr>
@@ -10519,7 +10519,7 @@
               </a:lnSpc>
             </a:pPr>
             <a:r>
-              <a:rPr lang="en-US" sz="1600" b="1" dirty="0">
+              <a:rPr lang="en-US" sz="1800" b="1" dirty="0">
                 <a:latin typeface="Times New Roman" panose="02020603050405020304" pitchFamily="18" charset="0"/>
                 <a:cs typeface="Times New Roman" panose="02020603050405020304" pitchFamily="18" charset="0"/>
               </a:rPr>
@@ -10535,7 +10535,7 @@
               <a:buChar char="•"/>
             </a:pPr>
             <a:r>
-              <a:rPr lang="en-US" sz="1600" dirty="0">
+              <a:rPr lang="en-US" sz="1800" dirty="0">
                 <a:latin typeface="Times New Roman" panose="02020603050405020304" pitchFamily="18" charset="0"/>
                 <a:cs typeface="Times New Roman" panose="02020603050405020304" pitchFamily="18" charset="0"/>
               </a:rPr>
@@ -10551,7 +10551,7 @@
               <a:buChar char="•"/>
             </a:pPr>
             <a:r>
-              <a:rPr lang="en-US" sz="1600" dirty="0">
+              <a:rPr lang="en-US" sz="1800" dirty="0">
                 <a:latin typeface="Times New Roman" panose="02020603050405020304" pitchFamily="18" charset="0"/>
                 <a:cs typeface="Times New Roman" panose="02020603050405020304" pitchFamily="18" charset="0"/>
               </a:rPr>
@@ -10567,7 +10567,7 @@
               <a:buChar char="•"/>
             </a:pPr>
             <a:r>
-              <a:rPr lang="en-US" sz="1600" dirty="0">
+              <a:rPr lang="en-US" sz="1800" dirty="0">
                 <a:latin typeface="Times New Roman" panose="02020603050405020304" pitchFamily="18" charset="0"/>
                 <a:cs typeface="Times New Roman" panose="02020603050405020304" pitchFamily="18" charset="0"/>
               </a:rPr>
@@ -10583,7 +10583,7 @@
               <a:buChar char="•"/>
             </a:pPr>
             <a:r>
-              <a:rPr lang="en-US" sz="1600" dirty="0">
+              <a:rPr lang="en-US" sz="1800" dirty="0">
                 <a:latin typeface="Times New Roman" panose="02020603050405020304" pitchFamily="18" charset="0"/>
                 <a:cs typeface="Times New Roman" panose="02020603050405020304" pitchFamily="18" charset="0"/>
               </a:rPr>
@@ -10597,7 +10597,7 @@
               </a:lnSpc>
             </a:pPr>
             <a:r>
-              <a:rPr lang="en-US" sz="1600" b="1" dirty="0">
+              <a:rPr lang="en-US" sz="1800" b="1" dirty="0">
                 <a:latin typeface="Times New Roman" panose="02020603050405020304" pitchFamily="18" charset="0"/>
                 <a:cs typeface="Times New Roman" panose="02020603050405020304" pitchFamily="18" charset="0"/>
               </a:rPr>
@@ -10613,7 +10613,7 @@
               <a:buChar char="•"/>
             </a:pPr>
             <a:r>
-              <a:rPr lang="en-US" sz="1600" dirty="0">
+              <a:rPr lang="en-US" sz="1800" dirty="0">
                 <a:latin typeface="Times New Roman" panose="02020603050405020304" pitchFamily="18" charset="0"/>
                 <a:cs typeface="Times New Roman" panose="02020603050405020304" pitchFamily="18" charset="0"/>
               </a:rPr>
@@ -10629,7 +10629,7 @@
               <a:buChar char="•"/>
             </a:pPr>
             <a:r>
-              <a:rPr lang="en-US" sz="1600" dirty="0">
+              <a:rPr lang="en-US" sz="1800" dirty="0">
                 <a:latin typeface="Times New Roman" panose="02020603050405020304" pitchFamily="18" charset="0"/>
                 <a:cs typeface="Times New Roman" panose="02020603050405020304" pitchFamily="18" charset="0"/>
               </a:rPr>
@@ -10645,7 +10645,7 @@
               <a:buChar char="•"/>
             </a:pPr>
             <a:r>
-              <a:rPr lang="en-US" sz="1600" dirty="0">
+              <a:rPr lang="en-US" sz="1800" dirty="0">
                 <a:latin typeface="Times New Roman" panose="02020603050405020304" pitchFamily="18" charset="0"/>
                 <a:cs typeface="Times New Roman" panose="02020603050405020304" pitchFamily="18" charset="0"/>
               </a:rPr>
@@ -10659,7 +10659,7 @@
               </a:lnSpc>
             </a:pPr>
             <a:r>
-              <a:rPr lang="en-US" sz="1600" b="1" dirty="0">
+              <a:rPr lang="en-US" sz="1800" b="1" dirty="0">
                 <a:latin typeface="Times New Roman" panose="02020603050405020304" pitchFamily="18" charset="0"/>
                 <a:cs typeface="Times New Roman" panose="02020603050405020304" pitchFamily="18" charset="0"/>
               </a:rPr>
@@ -10675,7 +10675,7 @@
               <a:buChar char="•"/>
             </a:pPr>
             <a:r>
-              <a:rPr lang="en-US" sz="1600" dirty="0">
+              <a:rPr lang="en-US" sz="1800" dirty="0">
                 <a:latin typeface="Times New Roman" panose="02020603050405020304" pitchFamily="18" charset="0"/>
                 <a:cs typeface="Times New Roman" panose="02020603050405020304" pitchFamily="18" charset="0"/>
               </a:rPr>
@@ -10691,7 +10691,7 @@
               <a:buChar char="•"/>
             </a:pPr>
             <a:r>
-              <a:rPr lang="en-US" sz="1600" dirty="0">
+              <a:rPr lang="en-US" sz="1800" dirty="0">
                 <a:latin typeface="Times New Roman" panose="02020603050405020304" pitchFamily="18" charset="0"/>
                 <a:cs typeface="Times New Roman" panose="02020603050405020304" pitchFamily="18" charset="0"/>
               </a:rPr>
@@ -10777,7 +10777,7 @@
               </a:lnSpc>
             </a:pPr>
             <a:r>
-              <a:rPr lang="en-US" sz="1600" b="1" dirty="0">
+              <a:rPr lang="en-US" sz="1800" b="1" dirty="0">
                 <a:latin typeface="Times New Roman" panose="02020603050405020304" pitchFamily="18" charset="0"/>
                 <a:cs typeface="Times New Roman" panose="02020603050405020304" pitchFamily="18" charset="0"/>
               </a:rPr>
@@ -10791,7 +10791,7 @@
               </a:lnSpc>
             </a:pPr>
             <a:r>
-              <a:rPr lang="en-US" sz="1600" dirty="0">
+              <a:rPr lang="en-US" sz="1800" dirty="0">
                 <a:latin typeface="Times New Roman" panose="02020603050405020304" pitchFamily="18" charset="0"/>
                 <a:cs typeface="Times New Roman" panose="02020603050405020304" pitchFamily="18" charset="0"/>
               </a:rPr>
@@ -10805,7 +10805,7 @@
               </a:lnSpc>
             </a:pPr>
             <a:r>
-              <a:rPr lang="en-US" sz="1600" b="1" dirty="0">
+              <a:rPr lang="en-US" sz="1800" b="1" dirty="0">
                 <a:latin typeface="Times New Roman" panose="02020603050405020304" pitchFamily="18" charset="0"/>
                 <a:cs typeface="Times New Roman" panose="02020603050405020304" pitchFamily="18" charset="0"/>
               </a:rPr>
@@ -10821,7 +10821,7 @@
               <a:buChar char="•"/>
             </a:pPr>
             <a:r>
-              <a:rPr lang="en-US" sz="1600" dirty="0">
+              <a:rPr lang="en-US" sz="1800" dirty="0">
                 <a:latin typeface="Times New Roman" panose="02020603050405020304" pitchFamily="18" charset="0"/>
                 <a:cs typeface="Times New Roman" panose="02020603050405020304" pitchFamily="18" charset="0"/>
               </a:rPr>
@@ -10837,7 +10837,7 @@
               <a:buChar char="•"/>
             </a:pPr>
             <a:r>
-              <a:rPr lang="en-US" sz="1600" dirty="0">
+              <a:rPr lang="en-US" sz="1800" dirty="0">
                 <a:latin typeface="Times New Roman" panose="02020603050405020304" pitchFamily="18" charset="0"/>
                 <a:cs typeface="Times New Roman" panose="02020603050405020304" pitchFamily="18" charset="0"/>
               </a:rPr>
@@ -10853,7 +10853,7 @@
               <a:buChar char="•"/>
             </a:pPr>
             <a:r>
-              <a:rPr lang="en-US" sz="1600" dirty="0">
+              <a:rPr lang="en-US" sz="1800" dirty="0">
                 <a:latin typeface="Times New Roman" panose="02020603050405020304" pitchFamily="18" charset="0"/>
                 <a:cs typeface="Times New Roman" panose="02020603050405020304" pitchFamily="18" charset="0"/>
               </a:rPr>
@@ -10869,7 +10869,7 @@
               <a:buChar char="•"/>
             </a:pPr>
             <a:r>
-              <a:rPr lang="en-US" sz="1600" dirty="0">
+              <a:rPr lang="en-US" sz="1800" dirty="0">
                 <a:latin typeface="Times New Roman" panose="02020603050405020304" pitchFamily="18" charset="0"/>
                 <a:cs typeface="Times New Roman" panose="02020603050405020304" pitchFamily="18" charset="0"/>
               </a:rPr>
@@ -10885,7 +10885,7 @@
               <a:buChar char="•"/>
             </a:pPr>
             <a:r>
-              <a:rPr lang="en-US" sz="1600" dirty="0">
+              <a:rPr lang="en-US" sz="1800" dirty="0">
                 <a:latin typeface="Times New Roman" panose="02020603050405020304" pitchFamily="18" charset="0"/>
                 <a:cs typeface="Times New Roman" panose="02020603050405020304" pitchFamily="18" charset="0"/>
               </a:rPr>
@@ -10899,7 +10899,7 @@
               </a:lnSpc>
             </a:pPr>
             <a:r>
-              <a:rPr lang="en-US" sz="1600" b="1" dirty="0">
+              <a:rPr lang="en-US" sz="1800" b="1" dirty="0">
                 <a:latin typeface="Times New Roman" panose="02020603050405020304" pitchFamily="18" charset="0"/>
                 <a:cs typeface="Times New Roman" panose="02020603050405020304" pitchFamily="18" charset="0"/>
               </a:rPr>
@@ -10915,7 +10915,7 @@
               <a:buChar char="•"/>
             </a:pPr>
             <a:r>
-              <a:rPr lang="en-US" sz="1600" dirty="0">
+              <a:rPr lang="en-US" sz="1800" dirty="0">
                 <a:latin typeface="Times New Roman" panose="02020603050405020304" pitchFamily="18" charset="0"/>
                 <a:cs typeface="Times New Roman" panose="02020603050405020304" pitchFamily="18" charset="0"/>
               </a:rPr>
@@ -10931,7 +10931,7 @@
               <a:buChar char="•"/>
             </a:pPr>
             <a:r>
-              <a:rPr lang="en-US" sz="1600" dirty="0">
+              <a:rPr lang="en-US" sz="1800" dirty="0">
                 <a:latin typeface="Times New Roman" panose="02020603050405020304" pitchFamily="18" charset="0"/>
                 <a:cs typeface="Times New Roman" panose="02020603050405020304" pitchFamily="18" charset="0"/>
               </a:rPr>
@@ -10945,7 +10945,7 @@
               </a:lnSpc>
             </a:pPr>
             <a:r>
-              <a:rPr lang="en-US" sz="1600" b="1" dirty="0">
+              <a:rPr lang="en-US" sz="1800" b="1" dirty="0">
                 <a:latin typeface="Times New Roman" panose="02020603050405020304" pitchFamily="18" charset="0"/>
                 <a:cs typeface="Times New Roman" panose="02020603050405020304" pitchFamily="18" charset="0"/>
               </a:rPr>
@@ -10961,7 +10961,7 @@
               <a:buChar char="•"/>
             </a:pPr>
             <a:r>
-              <a:rPr lang="en-US" sz="1600" dirty="0">
+              <a:rPr lang="en-US" sz="1800" dirty="0">
                 <a:latin typeface="Times New Roman" panose="02020603050405020304" pitchFamily="18" charset="0"/>
                 <a:cs typeface="Times New Roman" panose="02020603050405020304" pitchFamily="18" charset="0"/>
               </a:rPr>
@@ -10977,7 +10977,7 @@
               <a:buChar char="•"/>
             </a:pPr>
             <a:r>
-              <a:rPr lang="en-US" sz="1600" dirty="0">
+              <a:rPr lang="en-US" sz="1800" dirty="0">
                 <a:latin typeface="Times New Roman" panose="02020603050405020304" pitchFamily="18" charset="0"/>
                 <a:cs typeface="Times New Roman" panose="02020603050405020304" pitchFamily="18" charset="0"/>
               </a:rPr>
@@ -10993,7 +10993,7 @@
               <a:buChar char="•"/>
             </a:pPr>
             <a:r>
-              <a:rPr lang="en-US" sz="1600" dirty="0">
+              <a:rPr lang="en-US" sz="1800" dirty="0">
                 <a:latin typeface="Times New Roman" panose="02020603050405020304" pitchFamily="18" charset="0"/>
                 <a:cs typeface="Times New Roman" panose="02020603050405020304" pitchFamily="18" charset="0"/>
               </a:rPr>
@@ -11079,7 +11079,7 @@
               </a:lnSpc>
             </a:pPr>
             <a:r>
-              <a:rPr lang="en-US" sz="1600" b="1" dirty="0">
+              <a:rPr lang="en-US" sz="1800" b="1" dirty="0">
                 <a:latin typeface="Times New Roman" panose="02020603050405020304" pitchFamily="18" charset="0"/>
                 <a:cs typeface="Times New Roman" panose="02020603050405020304" pitchFamily="18" charset="0"/>
               </a:rPr>
@@ -11093,7 +11093,7 @@
               </a:lnSpc>
             </a:pPr>
             <a:r>
-              <a:rPr lang="en-US" sz="1600" dirty="0">
+              <a:rPr lang="en-US" sz="1800" dirty="0">
                 <a:latin typeface="Times New Roman" panose="02020603050405020304" pitchFamily="18" charset="0"/>
                 <a:cs typeface="Times New Roman" panose="02020603050405020304" pitchFamily="18" charset="0"/>
               </a:rPr>
@@ -11109,7 +11109,7 @@
               <a:buChar char="•"/>
             </a:pPr>
             <a:r>
-              <a:rPr lang="en-US" sz="1600" dirty="0">
+              <a:rPr lang="en-US" sz="1800" dirty="0">
                 <a:latin typeface="Times New Roman" panose="02020603050405020304" pitchFamily="18" charset="0"/>
                 <a:cs typeface="Times New Roman" panose="02020603050405020304" pitchFamily="18" charset="0"/>
               </a:rPr>
@@ -11125,7 +11125,7 @@
               <a:buChar char="•"/>
             </a:pPr>
             <a:r>
-              <a:rPr lang="en-US" sz="1600" dirty="0">
+              <a:rPr lang="en-US" sz="1800" dirty="0">
                 <a:latin typeface="Times New Roman" panose="02020603050405020304" pitchFamily="18" charset="0"/>
                 <a:cs typeface="Times New Roman" panose="02020603050405020304" pitchFamily="18" charset="0"/>
               </a:rPr>
@@ -11141,7 +11141,7 @@
               <a:buChar char="•"/>
             </a:pPr>
             <a:r>
-              <a:rPr lang="en-US" sz="1600" dirty="0">
+              <a:rPr lang="en-US" sz="1800" dirty="0">
                 <a:latin typeface="Times New Roman" panose="02020603050405020304" pitchFamily="18" charset="0"/>
                 <a:cs typeface="Times New Roman" panose="02020603050405020304" pitchFamily="18" charset="0"/>
               </a:rPr>
@@ -11157,7 +11157,7 @@
               <a:buChar char="•"/>
             </a:pPr>
             <a:r>
-              <a:rPr lang="en-US" sz="1600" dirty="0">
+              <a:rPr lang="en-US" sz="1800" dirty="0">
                 <a:latin typeface="Times New Roman" panose="02020603050405020304" pitchFamily="18" charset="0"/>
                 <a:cs typeface="Times New Roman" panose="02020603050405020304" pitchFamily="18" charset="0"/>
               </a:rPr>
@@ -11173,7 +11173,7 @@
               <a:buChar char="•"/>
             </a:pPr>
             <a:r>
-              <a:rPr lang="en-US" sz="1600" dirty="0">
+              <a:rPr lang="en-US" sz="1800" dirty="0">
                 <a:latin typeface="Times New Roman" panose="02020603050405020304" pitchFamily="18" charset="0"/>
                 <a:cs typeface="Times New Roman" panose="02020603050405020304" pitchFamily="18" charset="0"/>
               </a:rPr>
@@ -11189,7 +11189,7 @@
               <a:buChar char="•"/>
             </a:pPr>
             <a:r>
-              <a:rPr lang="en-US" sz="1600" dirty="0">
+              <a:rPr lang="en-US" sz="1800" dirty="0">
                 <a:latin typeface="Times New Roman" panose="02020603050405020304" pitchFamily="18" charset="0"/>
                 <a:cs typeface="Times New Roman" panose="02020603050405020304" pitchFamily="18" charset="0"/>
               </a:rPr>
@@ -11275,7 +11275,7 @@
               </a:lnSpc>
             </a:pPr>
             <a:r>
-              <a:rPr lang="en-US" sz="1600" b="1" dirty="0">
+              <a:rPr lang="en-US" sz="1800" b="1" dirty="0">
                 <a:latin typeface="Times New Roman" panose="02020603050405020304" pitchFamily="18" charset="0"/>
                 <a:cs typeface="Times New Roman" panose="02020603050405020304" pitchFamily="18" charset="0"/>
               </a:rPr>
@@ -11289,7 +11289,7 @@
               </a:lnSpc>
             </a:pPr>
             <a:r>
-              <a:rPr lang="en-US" sz="1600" dirty="0">
+              <a:rPr lang="en-US" sz="1800" dirty="0">
                 <a:latin typeface="Times New Roman" panose="02020603050405020304" pitchFamily="18" charset="0"/>
                 <a:cs typeface="Times New Roman" panose="02020603050405020304" pitchFamily="18" charset="0"/>
               </a:rPr>
@@ -11303,7 +11303,7 @@
               </a:lnSpc>
             </a:pPr>
             <a:r>
-              <a:rPr lang="en-US" sz="1600" b="1" dirty="0">
+              <a:rPr lang="en-US" sz="1800" b="1" dirty="0">
                 <a:latin typeface="Times New Roman" panose="02020603050405020304" pitchFamily="18" charset="0"/>
                 <a:cs typeface="Times New Roman" panose="02020603050405020304" pitchFamily="18" charset="0"/>
               </a:rPr>
@@ -11319,7 +11319,7 @@
               <a:buChar char="•"/>
             </a:pPr>
             <a:r>
-              <a:rPr lang="en-US" sz="1600" dirty="0">
+              <a:rPr lang="en-US" sz="1800" dirty="0">
                 <a:latin typeface="Times New Roman" panose="02020603050405020304" pitchFamily="18" charset="0"/>
                 <a:cs typeface="Times New Roman" panose="02020603050405020304" pitchFamily="18" charset="0"/>
               </a:rPr>
@@ -11335,7 +11335,7 @@
               <a:buChar char="•"/>
             </a:pPr>
             <a:r>
-              <a:rPr lang="en-US" sz="1600" dirty="0">
+              <a:rPr lang="en-US" sz="1800" dirty="0">
                 <a:latin typeface="Times New Roman" panose="02020603050405020304" pitchFamily="18" charset="0"/>
                 <a:cs typeface="Times New Roman" panose="02020603050405020304" pitchFamily="18" charset="0"/>
               </a:rPr>
@@ -11351,7 +11351,7 @@
               <a:buChar char="•"/>
             </a:pPr>
             <a:r>
-              <a:rPr lang="en-US" sz="1600" dirty="0">
+              <a:rPr lang="en-US" sz="1800" dirty="0">
                 <a:latin typeface="Times New Roman" panose="02020603050405020304" pitchFamily="18" charset="0"/>
                 <a:cs typeface="Times New Roman" panose="02020603050405020304" pitchFamily="18" charset="0"/>
               </a:rPr>
@@ -11367,7 +11367,7 @@
               <a:buChar char="•"/>
             </a:pPr>
             <a:r>
-              <a:rPr lang="en-US" sz="1600" dirty="0">
+              <a:rPr lang="en-US" sz="1800" dirty="0">
                 <a:latin typeface="Times New Roman" panose="02020603050405020304" pitchFamily="18" charset="0"/>
                 <a:cs typeface="Times New Roman" panose="02020603050405020304" pitchFamily="18" charset="0"/>
               </a:rPr>
@@ -11383,7 +11383,7 @@
               <a:buChar char="•"/>
             </a:pPr>
             <a:r>
-              <a:rPr lang="en-US" sz="1600" dirty="0">
+              <a:rPr lang="en-US" sz="1800" dirty="0">
                 <a:latin typeface="Times New Roman" panose="02020603050405020304" pitchFamily="18" charset="0"/>
                 <a:cs typeface="Times New Roman" panose="02020603050405020304" pitchFamily="18" charset="0"/>
               </a:rPr>
@@ -11397,7 +11397,7 @@
               </a:lnSpc>
             </a:pPr>
             <a:r>
-              <a:rPr lang="en-US" sz="1600" b="1" dirty="0">
+              <a:rPr lang="en-US" sz="1800" b="1" dirty="0">
                 <a:latin typeface="Times New Roman" panose="02020603050405020304" pitchFamily="18" charset="0"/>
                 <a:cs typeface="Times New Roman" panose="02020603050405020304" pitchFamily="18" charset="0"/>
               </a:rPr>
@@ -11413,7 +11413,7 @@
               <a:buChar char="•"/>
             </a:pPr>
             <a:r>
-              <a:rPr lang="en-US" sz="1600" dirty="0">
+              <a:rPr lang="en-US" sz="1800" dirty="0">
                 <a:latin typeface="Times New Roman" panose="02020603050405020304" pitchFamily="18" charset="0"/>
                 <a:cs typeface="Times New Roman" panose="02020603050405020304" pitchFamily="18" charset="0"/>
               </a:rPr>
@@ -11429,7 +11429,7 @@
               <a:buChar char="•"/>
             </a:pPr>
             <a:r>
-              <a:rPr lang="en-US" sz="1600" dirty="0">
+              <a:rPr lang="en-US" sz="1800" dirty="0">
                 <a:latin typeface="Times New Roman" panose="02020603050405020304" pitchFamily="18" charset="0"/>
                 <a:cs typeface="Times New Roman" panose="02020603050405020304" pitchFamily="18" charset="0"/>
               </a:rPr>
@@ -11445,7 +11445,7 @@
               <a:buChar char="•"/>
             </a:pPr>
             <a:r>
-              <a:rPr lang="en-US" sz="1600" dirty="0">
+              <a:rPr lang="en-US" sz="1800" dirty="0">
                 <a:latin typeface="Times New Roman" panose="02020603050405020304" pitchFamily="18" charset="0"/>
                 <a:cs typeface="Times New Roman" panose="02020603050405020304" pitchFamily="18" charset="0"/>
               </a:rPr>
@@ -11459,7 +11459,7 @@
               </a:lnSpc>
             </a:pPr>
             <a:r>
-              <a:rPr lang="en-US" sz="1600" b="1" dirty="0">
+              <a:rPr lang="en-US" sz="1800" b="1" dirty="0">
                 <a:latin typeface="Times New Roman" panose="02020603050405020304" pitchFamily="18" charset="0"/>
                 <a:cs typeface="Times New Roman" panose="02020603050405020304" pitchFamily="18" charset="0"/>
               </a:rPr>
@@ -11475,7 +11475,7 @@
               <a:buChar char="•"/>
             </a:pPr>
             <a:r>
-              <a:rPr lang="en-US" sz="1600" dirty="0">
+              <a:rPr lang="en-US" sz="1800" dirty="0">
                 <a:latin typeface="Times New Roman" panose="02020603050405020304" pitchFamily="18" charset="0"/>
                 <a:cs typeface="Times New Roman" panose="02020603050405020304" pitchFamily="18" charset="0"/>
               </a:rPr>
@@ -11491,7 +11491,7 @@
               <a:buChar char="•"/>
             </a:pPr>
             <a:r>
-              <a:rPr lang="en-US" sz="1600" dirty="0">
+              <a:rPr lang="en-US" sz="1800" dirty="0">
                 <a:latin typeface="Times New Roman" panose="02020603050405020304" pitchFamily="18" charset="0"/>
                 <a:cs typeface="Times New Roman" panose="02020603050405020304" pitchFamily="18" charset="0"/>
               </a:rPr>
@@ -11507,7 +11507,7 @@
               <a:buChar char="•"/>
             </a:pPr>
             <a:r>
-              <a:rPr lang="en-US" sz="1600" dirty="0">
+              <a:rPr lang="en-US" sz="1800" dirty="0">
                 <a:latin typeface="Times New Roman" panose="02020603050405020304" pitchFamily="18" charset="0"/>
                 <a:cs typeface="Times New Roman" panose="02020603050405020304" pitchFamily="18" charset="0"/>
               </a:rPr>
@@ -11593,7 +11593,7 @@
               </a:lnSpc>
             </a:pPr>
             <a:r>
-              <a:rPr lang="en-US" sz="1600" b="1" dirty="0">
+              <a:rPr lang="en-US" sz="1800" b="1" dirty="0">
                 <a:latin typeface="Times New Roman" panose="02020603050405020304" pitchFamily="18" charset="0"/>
                 <a:cs typeface="Times New Roman" panose="02020603050405020304" pitchFamily="18" charset="0"/>
               </a:rPr>
@@ -11607,7 +11607,7 @@
               </a:lnSpc>
             </a:pPr>
             <a:r>
-              <a:rPr lang="en-US" sz="1600" dirty="0">
+              <a:rPr lang="en-US" sz="1800" dirty="0">
                 <a:latin typeface="Times New Roman" panose="02020603050405020304" pitchFamily="18" charset="0"/>
                 <a:cs typeface="Times New Roman" panose="02020603050405020304" pitchFamily="18" charset="0"/>
               </a:rPr>
@@ -11621,7 +11621,7 @@
               </a:lnSpc>
             </a:pPr>
             <a:r>
-              <a:rPr lang="en-US" sz="1600" b="1" dirty="0">
+              <a:rPr lang="en-US" sz="1800" b="1" dirty="0">
                 <a:latin typeface="Times New Roman" panose="02020603050405020304" pitchFamily="18" charset="0"/>
                 <a:cs typeface="Times New Roman" panose="02020603050405020304" pitchFamily="18" charset="0"/>
               </a:rPr>
@@ -11637,7 +11637,7 @@
               <a:buChar char="•"/>
             </a:pPr>
             <a:r>
-              <a:rPr lang="en-US" sz="1600" dirty="0">
+              <a:rPr lang="en-US" sz="1800" dirty="0">
                 <a:latin typeface="Times New Roman" panose="02020603050405020304" pitchFamily="18" charset="0"/>
                 <a:cs typeface="Times New Roman" panose="02020603050405020304" pitchFamily="18" charset="0"/>
               </a:rPr>
@@ -11653,7 +11653,7 @@
               <a:buChar char="•"/>
             </a:pPr>
             <a:r>
-              <a:rPr lang="en-US" sz="1600" dirty="0">
+              <a:rPr lang="en-US" sz="1800" dirty="0">
                 <a:latin typeface="Times New Roman" panose="02020603050405020304" pitchFamily="18" charset="0"/>
                 <a:cs typeface="Times New Roman" panose="02020603050405020304" pitchFamily="18" charset="0"/>
               </a:rPr>
@@ -11669,7 +11669,7 @@
               <a:buChar char="•"/>
             </a:pPr>
             <a:r>
-              <a:rPr lang="en-US" sz="1600" dirty="0">
+              <a:rPr lang="en-US" sz="1800" dirty="0">
                 <a:latin typeface="Times New Roman" panose="02020603050405020304" pitchFamily="18" charset="0"/>
                 <a:cs typeface="Times New Roman" panose="02020603050405020304" pitchFamily="18" charset="0"/>
               </a:rPr>
@@ -11685,7 +11685,7 @@
               <a:buChar char="•"/>
             </a:pPr>
             <a:r>
-              <a:rPr lang="en-US" sz="1600" dirty="0">
+              <a:rPr lang="en-US" sz="1800" dirty="0">
                 <a:latin typeface="Times New Roman" panose="02020603050405020304" pitchFamily="18" charset="0"/>
                 <a:cs typeface="Times New Roman" panose="02020603050405020304" pitchFamily="18" charset="0"/>
               </a:rPr>
@@ -11701,7 +11701,7 @@
               <a:buChar char="•"/>
             </a:pPr>
             <a:r>
-              <a:rPr lang="en-US" sz="1600" dirty="0">
+              <a:rPr lang="en-US" sz="1800" dirty="0">
                 <a:latin typeface="Times New Roman" panose="02020603050405020304" pitchFamily="18" charset="0"/>
                 <a:cs typeface="Times New Roman" panose="02020603050405020304" pitchFamily="18" charset="0"/>
               </a:rPr>
@@ -11715,7 +11715,7 @@
               </a:lnSpc>
             </a:pPr>
             <a:r>
-              <a:rPr lang="en-US" sz="1600" b="1" dirty="0">
+              <a:rPr lang="en-US" sz="1800" b="1" dirty="0">
                 <a:latin typeface="Times New Roman" panose="02020603050405020304" pitchFamily="18" charset="0"/>
                 <a:cs typeface="Times New Roman" panose="02020603050405020304" pitchFamily="18" charset="0"/>
               </a:rPr>
@@ -11731,7 +11731,7 @@
               <a:buChar char="•"/>
             </a:pPr>
             <a:r>
-              <a:rPr lang="en-US" sz="1600" dirty="0">
+              <a:rPr lang="en-US" sz="1800" dirty="0">
                 <a:latin typeface="Times New Roman" panose="02020603050405020304" pitchFamily="18" charset="0"/>
                 <a:cs typeface="Times New Roman" panose="02020603050405020304" pitchFamily="18" charset="0"/>
               </a:rPr>
@@ -11747,7 +11747,7 @@
               <a:buChar char="•"/>
             </a:pPr>
             <a:r>
-              <a:rPr lang="en-US" sz="1600" dirty="0">
+              <a:rPr lang="en-US" sz="1800" dirty="0">
                 <a:latin typeface="Times New Roman" panose="02020603050405020304" pitchFamily="18" charset="0"/>
                 <a:cs typeface="Times New Roman" panose="02020603050405020304" pitchFamily="18" charset="0"/>
               </a:rPr>
@@ -11833,7 +11833,7 @@
               </a:lnSpc>
             </a:pPr>
             <a:r>
-              <a:rPr lang="en-US" sz="1600" b="1" dirty="0">
+              <a:rPr lang="en-US" sz="1800" b="1" dirty="0">
                 <a:latin typeface="Times New Roman" panose="02020603050405020304" pitchFamily="18" charset="0"/>
                 <a:cs typeface="Times New Roman" panose="02020603050405020304" pitchFamily="18" charset="0"/>
               </a:rPr>
@@ -11847,7 +11847,7 @@
               </a:lnSpc>
             </a:pPr>
             <a:r>
-              <a:rPr lang="en-US" sz="1600" dirty="0">
+              <a:rPr lang="en-US" sz="1800" dirty="0">
                 <a:latin typeface="Times New Roman" panose="02020603050405020304" pitchFamily="18" charset="0"/>
                 <a:cs typeface="Times New Roman" panose="02020603050405020304" pitchFamily="18" charset="0"/>
               </a:rPr>
@@ -11861,7 +11861,7 @@
               </a:lnSpc>
             </a:pPr>
             <a:r>
-              <a:rPr lang="en-US" sz="1600" b="1" dirty="0">
+              <a:rPr lang="en-US" sz="1800" b="1" dirty="0">
                 <a:latin typeface="Times New Roman" panose="02020603050405020304" pitchFamily="18" charset="0"/>
                 <a:cs typeface="Times New Roman" panose="02020603050405020304" pitchFamily="18" charset="0"/>
               </a:rPr>
@@ -11877,7 +11877,7 @@
               <a:buChar char="•"/>
             </a:pPr>
             <a:r>
-              <a:rPr lang="en-US" sz="1600" dirty="0">
+              <a:rPr lang="en-US" sz="1800" dirty="0">
                 <a:latin typeface="Times New Roman" panose="02020603050405020304" pitchFamily="18" charset="0"/>
                 <a:cs typeface="Times New Roman" panose="02020603050405020304" pitchFamily="18" charset="0"/>
               </a:rPr>
@@ -11893,7 +11893,7 @@
               <a:buChar char="•"/>
             </a:pPr>
             <a:r>
-              <a:rPr lang="en-US" sz="1600" dirty="0">
+              <a:rPr lang="en-US" sz="1800" dirty="0">
                 <a:latin typeface="Times New Roman" panose="02020603050405020304" pitchFamily="18" charset="0"/>
                 <a:cs typeface="Times New Roman" panose="02020603050405020304" pitchFamily="18" charset="0"/>
               </a:rPr>
@@ -11909,7 +11909,7 @@
               <a:buChar char="•"/>
             </a:pPr>
             <a:r>
-              <a:rPr lang="en-US" sz="1600" dirty="0">
+              <a:rPr lang="en-US" sz="1800" dirty="0">
                 <a:latin typeface="Times New Roman" panose="02020603050405020304" pitchFamily="18" charset="0"/>
                 <a:cs typeface="Times New Roman" panose="02020603050405020304" pitchFamily="18" charset="0"/>
               </a:rPr>
@@ -11925,7 +11925,7 @@
               <a:buChar char="•"/>
             </a:pPr>
             <a:r>
-              <a:rPr lang="en-US" sz="1600" dirty="0">
+              <a:rPr lang="en-US" sz="1800" dirty="0">
                 <a:latin typeface="Times New Roman" panose="02020603050405020304" pitchFamily="18" charset="0"/>
                 <a:cs typeface="Times New Roman" panose="02020603050405020304" pitchFamily="18" charset="0"/>
               </a:rPr>
@@ -11941,7 +11941,7 @@
               <a:buChar char="•"/>
             </a:pPr>
             <a:r>
-              <a:rPr lang="en-US" sz="1600" dirty="0">
+              <a:rPr lang="en-US" sz="1800" dirty="0">
                 <a:latin typeface="Times New Roman" panose="02020603050405020304" pitchFamily="18" charset="0"/>
                 <a:cs typeface="Times New Roman" panose="02020603050405020304" pitchFamily="18" charset="0"/>
               </a:rPr>
@@ -11957,7 +11957,7 @@
               <a:buChar char="•"/>
             </a:pPr>
             <a:r>
-              <a:rPr lang="en-US" sz="1600" dirty="0">
+              <a:rPr lang="en-US" sz="1800" dirty="0">
                 <a:latin typeface="Times New Roman" panose="02020603050405020304" pitchFamily="18" charset="0"/>
                 <a:cs typeface="Times New Roman" panose="02020603050405020304" pitchFamily="18" charset="0"/>
               </a:rPr>
@@ -11971,7 +11971,7 @@
               </a:lnSpc>
             </a:pPr>
             <a:r>
-              <a:rPr lang="en-US" sz="1600" b="1" dirty="0">
+              <a:rPr lang="en-US" sz="1800" b="1" dirty="0">
                 <a:latin typeface="Times New Roman" panose="02020603050405020304" pitchFamily="18" charset="0"/>
                 <a:cs typeface="Times New Roman" panose="02020603050405020304" pitchFamily="18" charset="0"/>
               </a:rPr>
@@ -11987,7 +11987,7 @@
               <a:buChar char="•"/>
             </a:pPr>
             <a:r>
-              <a:rPr lang="en-US" sz="1600" dirty="0">
+              <a:rPr lang="en-US" sz="1800" dirty="0">
                 <a:latin typeface="Times New Roman" panose="02020603050405020304" pitchFamily="18" charset="0"/>
                 <a:cs typeface="Times New Roman" panose="02020603050405020304" pitchFamily="18" charset="0"/>
               </a:rPr>
@@ -12003,7 +12003,7 @@
               <a:buChar char="•"/>
             </a:pPr>
             <a:r>
-              <a:rPr lang="en-US" sz="1600" dirty="0">
+              <a:rPr lang="en-US" sz="1800" dirty="0">
                 <a:latin typeface="Times New Roman" panose="02020603050405020304" pitchFamily="18" charset="0"/>
                 <a:cs typeface="Times New Roman" panose="02020603050405020304" pitchFamily="18" charset="0"/>
               </a:rPr>
@@ -12019,7 +12019,7 @@
               <a:buChar char="•"/>
             </a:pPr>
             <a:r>
-              <a:rPr lang="en-US" sz="1600" dirty="0">
+              <a:rPr lang="en-US" sz="1800" dirty="0">
                 <a:latin typeface="Times New Roman" panose="02020603050405020304" pitchFamily="18" charset="0"/>
                 <a:cs typeface="Times New Roman" panose="02020603050405020304" pitchFamily="18" charset="0"/>
               </a:rPr>
@@ -12105,7 +12105,7 @@
               </a:lnSpc>
             </a:pPr>
             <a:r>
-              <a:rPr lang="en-US" sz="1600" b="1" dirty="0">
+              <a:rPr lang="en-US" sz="1800" b="1" dirty="0">
                 <a:latin typeface="Times New Roman" panose="02020603050405020304" pitchFamily="18" charset="0"/>
                 <a:cs typeface="Times New Roman" panose="02020603050405020304" pitchFamily="18" charset="0"/>
               </a:rPr>
@@ -12119,7 +12119,7 @@
               </a:lnSpc>
             </a:pPr>
             <a:r>
-              <a:rPr lang="en-US" sz="1600" dirty="0">
+              <a:rPr lang="en-US" sz="1800" dirty="0">
                 <a:latin typeface="Times New Roman" panose="02020603050405020304" pitchFamily="18" charset="0"/>
                 <a:cs typeface="Times New Roman" panose="02020603050405020304" pitchFamily="18" charset="0"/>
               </a:rPr>
@@ -12135,7 +12135,7 @@
               <a:buChar char="•"/>
             </a:pPr>
             <a:r>
-              <a:rPr lang="en-US" sz="1600" dirty="0">
+              <a:rPr lang="en-US" sz="1800" dirty="0">
                 <a:latin typeface="Times New Roman" panose="02020603050405020304" pitchFamily="18" charset="0"/>
                 <a:cs typeface="Times New Roman" panose="02020603050405020304" pitchFamily="18" charset="0"/>
               </a:rPr>
@@ -12149,7 +12149,7 @@
               </a:lnSpc>
             </a:pPr>
             <a:r>
-              <a:rPr lang="en-US" sz="1600" dirty="0">
+              <a:rPr lang="en-US" sz="1800" dirty="0">
                 <a:latin typeface="Times New Roman" panose="02020603050405020304" pitchFamily="18" charset="0"/>
                 <a:cs typeface="Times New Roman" panose="02020603050405020304" pitchFamily="18" charset="0"/>
               </a:rPr>
@@ -12165,7 +12165,7 @@
               <a:buChar char="•"/>
             </a:pPr>
             <a:r>
-              <a:rPr lang="en-US" sz="1600" dirty="0">
+              <a:rPr lang="en-US" sz="1800" dirty="0">
                 <a:latin typeface="Times New Roman" panose="02020603050405020304" pitchFamily="18" charset="0"/>
                 <a:cs typeface="Times New Roman" panose="02020603050405020304" pitchFamily="18" charset="0"/>
               </a:rPr>
@@ -12181,7 +12181,7 @@
               <a:buChar char="•"/>
             </a:pPr>
             <a:r>
-              <a:rPr lang="en-US" sz="1600" dirty="0">
+              <a:rPr lang="en-US" sz="1800" dirty="0">
                 <a:latin typeface="Times New Roman" panose="02020603050405020304" pitchFamily="18" charset="0"/>
                 <a:cs typeface="Times New Roman" panose="02020603050405020304" pitchFamily="18" charset="0"/>
               </a:rPr>
@@ -12197,7 +12197,7 @@
               <a:buChar char="•"/>
             </a:pPr>
             <a:r>
-              <a:rPr lang="en-US" sz="1600" dirty="0">
+              <a:rPr lang="en-US" sz="1800" dirty="0">
                 <a:latin typeface="Times New Roman" panose="02020603050405020304" pitchFamily="18" charset="0"/>
                 <a:cs typeface="Times New Roman" panose="02020603050405020304" pitchFamily="18" charset="0"/>
               </a:rPr>
@@ -12213,7 +12213,7 @@
               <a:buChar char="•"/>
             </a:pPr>
             <a:r>
-              <a:rPr lang="en-US" sz="1600" dirty="0">
+              <a:rPr lang="en-US" sz="1800" dirty="0">
                 <a:latin typeface="Times New Roman" panose="02020603050405020304" pitchFamily="18" charset="0"/>
                 <a:cs typeface="Times New Roman" panose="02020603050405020304" pitchFamily="18" charset="0"/>
               </a:rPr>
@@ -12229,7 +12229,7 @@
               <a:buChar char="•"/>
             </a:pPr>
             <a:r>
-              <a:rPr lang="en-US" sz="1600" dirty="0">
+              <a:rPr lang="en-US" sz="1800" dirty="0">
                 <a:latin typeface="Times New Roman" panose="02020603050405020304" pitchFamily="18" charset="0"/>
                 <a:cs typeface="Times New Roman" panose="02020603050405020304" pitchFamily="18" charset="0"/>
               </a:rPr>
@@ -12315,14 +12315,14 @@
               </a:lnSpc>
             </a:pPr>
             <a:r>
-              <a:rPr lang="en-US" sz="1600" b="1" dirty="0">
+              <a:rPr lang="en-US" sz="1800" b="1" dirty="0">
                 <a:latin typeface="Times New Roman" panose="02020603050405020304" pitchFamily="18" charset="0"/>
                 <a:cs typeface="Times New Roman" panose="02020603050405020304" pitchFamily="18" charset="0"/>
               </a:rPr>
               <a:t>Reason for Consultation: </a:t>
             </a:r>
             <a:r>
-              <a:rPr lang="en-US" sz="1600" dirty="0">
+              <a:rPr lang="en-US" sz="1800" dirty="0">
                 <a:latin typeface="Times New Roman" panose="02020603050405020304" pitchFamily="18" charset="0"/>
                 <a:cs typeface="Times New Roman" panose="02020603050405020304" pitchFamily="18" charset="0"/>
               </a:rPr>
@@ -12336,14 +12336,14 @@
               </a:lnSpc>
             </a:pPr>
             <a:r>
-              <a:rPr lang="en-US" sz="1600" b="1" dirty="0">
+              <a:rPr lang="en-US" sz="1800" b="1" dirty="0">
                 <a:latin typeface="Times New Roman" panose="02020603050405020304" pitchFamily="18" charset="0"/>
                 <a:cs typeface="Times New Roman" panose="02020603050405020304" pitchFamily="18" charset="0"/>
               </a:rPr>
               <a:t>Total Duration: </a:t>
             </a:r>
             <a:r>
-              <a:rPr lang="en-US" sz="1600" dirty="0">
+              <a:rPr lang="en-US" sz="1800" dirty="0">
                 <a:latin typeface="Times New Roman" panose="02020603050405020304" pitchFamily="18" charset="0"/>
                 <a:cs typeface="Times New Roman" panose="02020603050405020304" pitchFamily="18" charset="0"/>
               </a:rPr>
@@ -12357,14 +12357,14 @@
               </a:lnSpc>
             </a:pPr>
             <a:r>
-              <a:rPr lang="en-US" sz="1600" b="1" dirty="0">
+              <a:rPr lang="en-US" sz="1800" b="1" dirty="0">
                 <a:latin typeface="Times New Roman" panose="02020603050405020304" pitchFamily="18" charset="0"/>
                 <a:cs typeface="Times New Roman" panose="02020603050405020304" pitchFamily="18" charset="0"/>
               </a:rPr>
               <a:t>Onset: </a:t>
             </a:r>
             <a:r>
-              <a:rPr lang="en-US" sz="1600" dirty="0">
+              <a:rPr lang="en-US" sz="1800" dirty="0">
                 <a:latin typeface="Times New Roman" panose="02020603050405020304" pitchFamily="18" charset="0"/>
                 <a:cs typeface="Times New Roman" panose="02020603050405020304" pitchFamily="18" charset="0"/>
               </a:rPr>
@@ -12378,14 +12378,14 @@
               </a:lnSpc>
             </a:pPr>
             <a:r>
-              <a:rPr lang="en-US" sz="1600" b="1" dirty="0">
+              <a:rPr lang="en-US" sz="1800" b="1" dirty="0">
                 <a:latin typeface="Times New Roman" panose="02020603050405020304" pitchFamily="18" charset="0"/>
                 <a:cs typeface="Times New Roman" panose="02020603050405020304" pitchFamily="18" charset="0"/>
               </a:rPr>
               <a:t>Course: </a:t>
             </a:r>
             <a:r>
-              <a:rPr lang="en-US" sz="1600" dirty="0">
+              <a:rPr lang="en-US" sz="1800" dirty="0">
                 <a:latin typeface="Times New Roman" panose="02020603050405020304" pitchFamily="18" charset="0"/>
                 <a:cs typeface="Times New Roman" panose="02020603050405020304" pitchFamily="18" charset="0"/>
               </a:rPr>
@@ -12399,14 +12399,14 @@
               </a:lnSpc>
             </a:pPr>
             <a:r>
-              <a:rPr lang="en-US" sz="1600" b="1" dirty="0">
+              <a:rPr lang="en-US" sz="1800" b="1" dirty="0">
                 <a:latin typeface="Times New Roman" panose="02020603050405020304" pitchFamily="18" charset="0"/>
                 <a:cs typeface="Times New Roman" panose="02020603050405020304" pitchFamily="18" charset="0"/>
               </a:rPr>
               <a:t>Progress: </a:t>
             </a:r>
             <a:r>
-              <a:rPr lang="en-US" sz="1600" dirty="0">
+              <a:rPr lang="en-US" sz="1800" dirty="0">
                 <a:latin typeface="Times New Roman" panose="02020603050405020304" pitchFamily="18" charset="0"/>
                 <a:cs typeface="Times New Roman" panose="02020603050405020304" pitchFamily="18" charset="0"/>
               </a:rPr>
@@ -12420,7 +12420,7 @@
               </a:lnSpc>
             </a:pPr>
             <a:r>
-              <a:rPr lang="en-US" sz="1600" dirty="0">
+              <a:rPr lang="en-US" sz="1800" dirty="0">
                 <a:latin typeface="Times New Roman" panose="02020603050405020304" pitchFamily="18" charset="0"/>
                 <a:cs typeface="Times New Roman" panose="02020603050405020304" pitchFamily="18" charset="0"/>
               </a:rPr>
@@ -12434,14 +12434,14 @@
               </a:lnSpc>
             </a:pPr>
             <a:r>
-              <a:rPr lang="en-US" sz="1600" b="1" dirty="0">
+              <a:rPr lang="en-US" sz="1800" b="1" dirty="0">
                 <a:latin typeface="Times New Roman" panose="02020603050405020304" pitchFamily="18" charset="0"/>
                 <a:cs typeface="Times New Roman" panose="02020603050405020304" pitchFamily="18" charset="0"/>
               </a:rPr>
               <a:t>Predisposing Factor: </a:t>
             </a:r>
             <a:r>
-              <a:rPr lang="en-US" sz="1600" dirty="0">
+              <a:rPr lang="en-US" sz="1800" dirty="0">
                 <a:latin typeface="Times New Roman" panose="02020603050405020304" pitchFamily="18" charset="0"/>
                 <a:cs typeface="Times New Roman" panose="02020603050405020304" pitchFamily="18" charset="0"/>
               </a:rPr>
@@ -12455,14 +12455,14 @@
               </a:lnSpc>
             </a:pPr>
             <a:r>
-              <a:rPr lang="en-US" sz="1600" b="1" dirty="0">
+              <a:rPr lang="en-US" sz="1800" b="1" dirty="0">
                 <a:latin typeface="Times New Roman" panose="02020603050405020304" pitchFamily="18" charset="0"/>
                 <a:cs typeface="Times New Roman" panose="02020603050405020304" pitchFamily="18" charset="0"/>
               </a:rPr>
               <a:t>Precipitating Factor: </a:t>
             </a:r>
             <a:r>
-              <a:rPr lang="en-US" sz="1600" dirty="0">
+              <a:rPr lang="en-US" sz="1800" dirty="0">
                 <a:latin typeface="Times New Roman" panose="02020603050405020304" pitchFamily="18" charset="0"/>
                 <a:cs typeface="Times New Roman" panose="02020603050405020304" pitchFamily="18" charset="0"/>
               </a:rPr>
@@ -12476,14 +12476,14 @@
               </a:lnSpc>
             </a:pPr>
             <a:r>
-              <a:rPr lang="en-US" sz="1600" b="1" dirty="0">
+              <a:rPr lang="en-US" sz="1800" b="1" dirty="0">
                 <a:latin typeface="Times New Roman" panose="02020603050405020304" pitchFamily="18" charset="0"/>
                 <a:cs typeface="Times New Roman" panose="02020603050405020304" pitchFamily="18" charset="0"/>
               </a:rPr>
               <a:t>Perpetuating Factor: </a:t>
             </a:r>
             <a:r>
-              <a:rPr lang="en-US" sz="1600" dirty="0">
+              <a:rPr lang="en-US" sz="1800" dirty="0">
                 <a:latin typeface="Times New Roman" panose="02020603050405020304" pitchFamily="18" charset="0"/>
                 <a:cs typeface="Times New Roman" panose="02020603050405020304" pitchFamily="18" charset="0"/>
               </a:rPr>
@@ -12569,7 +12569,7 @@
               </a:lnSpc>
             </a:pPr>
             <a:r>
-              <a:rPr lang="en-US" sz="1600" b="1" dirty="0">
+              <a:rPr lang="en-US" sz="1800" b="1" dirty="0">
                 <a:latin typeface="Times New Roman" panose="02020603050405020304" pitchFamily="18" charset="0"/>
                 <a:cs typeface="Times New Roman" panose="02020603050405020304" pitchFamily="18" charset="0"/>
               </a:rPr>
@@ -12583,7 +12583,7 @@
               </a:lnSpc>
             </a:pPr>
             <a:r>
-              <a:rPr lang="en-US" sz="1600" dirty="0">
+              <a:rPr lang="en-US" sz="1800" dirty="0">
                 <a:latin typeface="Times New Roman" panose="02020603050405020304" pitchFamily="18" charset="0"/>
                 <a:cs typeface="Times New Roman" panose="02020603050405020304" pitchFamily="18" charset="0"/>
               </a:rPr>
@@ -12597,7 +12597,7 @@
               </a:lnSpc>
             </a:pPr>
             <a:r>
-              <a:rPr lang="en-US" sz="1600" dirty="0">
+              <a:rPr lang="en-US" sz="1800" dirty="0">
                 <a:latin typeface="Times New Roman" panose="02020603050405020304" pitchFamily="18" charset="0"/>
                 <a:cs typeface="Times New Roman" panose="02020603050405020304" pitchFamily="18" charset="0"/>
               </a:rPr>
@@ -12683,7 +12683,7 @@
               </a:lnSpc>
             </a:pPr>
             <a:r>
-              <a:rPr lang="en-US" sz="1600" b="1" dirty="0">
+              <a:rPr lang="en-US" sz="1800" b="1" dirty="0">
                 <a:latin typeface="Times New Roman" panose="02020603050405020304" pitchFamily="18" charset="0"/>
                 <a:cs typeface="Times New Roman" panose="02020603050405020304" pitchFamily="18" charset="0"/>
               </a:rPr>
@@ -12697,7 +12697,7 @@
               </a:lnSpc>
             </a:pPr>
             <a:r>
-              <a:rPr lang="en-US" sz="1600" dirty="0">
+              <a:rPr lang="en-US" sz="1800" dirty="0">
                 <a:latin typeface="Times New Roman" panose="02020603050405020304" pitchFamily="18" charset="0"/>
                 <a:cs typeface="Times New Roman" panose="02020603050405020304" pitchFamily="18" charset="0"/>
               </a:rPr>
@@ -12711,7 +12711,7 @@
               </a:lnSpc>
             </a:pPr>
             <a:r>
-              <a:rPr lang="en-US" sz="1600" dirty="0">
+              <a:rPr lang="en-US" sz="1800" dirty="0">
                 <a:latin typeface="Times New Roman" panose="02020603050405020304" pitchFamily="18" charset="0"/>
                 <a:cs typeface="Times New Roman" panose="02020603050405020304" pitchFamily="18" charset="0"/>
               </a:rPr>
@@ -12797,7 +12797,7 @@
               </a:lnSpc>
             </a:pPr>
             <a:r>
-              <a:rPr lang="en-US" sz="1600" b="1" dirty="0">
+              <a:rPr lang="en-US" sz="1800" b="1" dirty="0">
                 <a:latin typeface="Times New Roman" panose="02020603050405020304" pitchFamily="18" charset="0"/>
                 <a:cs typeface="Times New Roman" panose="02020603050405020304" pitchFamily="18" charset="0"/>
               </a:rPr>
@@ -12811,7 +12811,7 @@
               </a:lnSpc>
             </a:pPr>
             <a:r>
-              <a:rPr lang="en-US" sz="1600" dirty="0">
+              <a:rPr lang="en-US" sz="1800" dirty="0">
                 <a:latin typeface="Times New Roman" panose="02020603050405020304" pitchFamily="18" charset="0"/>
                 <a:cs typeface="Times New Roman" panose="02020603050405020304" pitchFamily="18" charset="0"/>
               </a:rPr>
@@ -12825,14 +12825,14 @@
               </a:lnSpc>
             </a:pPr>
             <a:r>
-              <a:rPr lang="en-US" sz="1600" b="1" dirty="0">
+              <a:rPr lang="en-US" sz="1800" b="1" dirty="0">
                 <a:latin typeface="Times New Roman" panose="02020603050405020304" pitchFamily="18" charset="0"/>
                 <a:cs typeface="Times New Roman" panose="02020603050405020304" pitchFamily="18" charset="0"/>
               </a:rPr>
               <a:t>Sleep: </a:t>
             </a:r>
             <a:r>
-              <a:rPr lang="en-US" sz="1600" dirty="0">
+              <a:rPr lang="en-US" sz="1800" dirty="0">
                 <a:latin typeface="Times New Roman" panose="02020603050405020304" pitchFamily="18" charset="0"/>
                 <a:cs typeface="Times New Roman" panose="02020603050405020304" pitchFamily="18" charset="0"/>
               </a:rPr>
@@ -12846,14 +12846,14 @@
               </a:lnSpc>
             </a:pPr>
             <a:r>
-              <a:rPr lang="en-US" sz="1600" b="1" dirty="0">
+              <a:rPr lang="en-US" sz="1800" b="1" dirty="0">
                 <a:latin typeface="Times New Roman" panose="02020603050405020304" pitchFamily="18" charset="0"/>
                 <a:cs typeface="Times New Roman" panose="02020603050405020304" pitchFamily="18" charset="0"/>
               </a:rPr>
               <a:t>Appetite: </a:t>
             </a:r>
             <a:r>
-              <a:rPr lang="en-US" sz="1600" dirty="0">
+              <a:rPr lang="en-US" sz="1800" dirty="0">
                 <a:latin typeface="Times New Roman" panose="02020603050405020304" pitchFamily="18" charset="0"/>
                 <a:cs typeface="Times New Roman" panose="02020603050405020304" pitchFamily="18" charset="0"/>
               </a:rPr>
@@ -12867,14 +12867,14 @@
               </a:lnSpc>
             </a:pPr>
             <a:r>
-              <a:rPr lang="en-US" sz="1600" b="1" dirty="0">
+              <a:rPr lang="en-US" sz="1800" b="1" dirty="0">
                 <a:latin typeface="Times New Roman" panose="02020603050405020304" pitchFamily="18" charset="0"/>
                 <a:cs typeface="Times New Roman" panose="02020603050405020304" pitchFamily="18" charset="0"/>
               </a:rPr>
               <a:t>Self-care: </a:t>
             </a:r>
             <a:r>
-              <a:rPr lang="en-US" sz="1600" dirty="0">
+              <a:rPr lang="en-US" sz="1800" dirty="0">
                 <a:latin typeface="Times New Roman" panose="02020603050405020304" pitchFamily="18" charset="0"/>
                 <a:cs typeface="Times New Roman" panose="02020603050405020304" pitchFamily="18" charset="0"/>
               </a:rPr>
@@ -12888,14 +12888,14 @@
               </a:lnSpc>
             </a:pPr>
             <a:r>
-              <a:rPr lang="en-US" sz="1600" b="1" dirty="0">
+              <a:rPr lang="en-US" sz="1800" b="1" dirty="0">
                 <a:latin typeface="Times New Roman" panose="02020603050405020304" pitchFamily="18" charset="0"/>
                 <a:cs typeface="Times New Roman" panose="02020603050405020304" pitchFamily="18" charset="0"/>
               </a:rPr>
               <a:t>Bowel and Bladder: </a:t>
             </a:r>
             <a:r>
-              <a:rPr lang="en-US" sz="1600" dirty="0">
+              <a:rPr lang="en-US" sz="1800" dirty="0">
                 <a:latin typeface="Times New Roman" panose="02020603050405020304" pitchFamily="18" charset="0"/>
                 <a:cs typeface="Times New Roman" panose="02020603050405020304" pitchFamily="18" charset="0"/>
               </a:rPr>
@@ -12909,14 +12909,14 @@
               </a:lnSpc>
             </a:pPr>
             <a:r>
-              <a:rPr lang="en-US" sz="1600" b="1" dirty="0">
+              <a:rPr lang="en-US" sz="1800" b="1" dirty="0">
                 <a:latin typeface="Times New Roman" panose="02020603050405020304" pitchFamily="18" charset="0"/>
                 <a:cs typeface="Times New Roman" panose="02020603050405020304" pitchFamily="18" charset="0"/>
               </a:rPr>
               <a:t>Libido: </a:t>
             </a:r>
             <a:r>
-              <a:rPr lang="en-US" sz="1600" dirty="0">
+              <a:rPr lang="en-US" sz="1800" dirty="0">
                 <a:latin typeface="Times New Roman" panose="02020603050405020304" pitchFamily="18" charset="0"/>
                 <a:cs typeface="Times New Roman" panose="02020603050405020304" pitchFamily="18" charset="0"/>
               </a:rPr>
@@ -12930,14 +12930,14 @@
               </a:lnSpc>
             </a:pPr>
             <a:r>
-              <a:rPr lang="en-US" sz="1600" b="1" dirty="0">
+              <a:rPr lang="en-US" sz="1800" b="1" dirty="0">
                 <a:latin typeface="Times New Roman" panose="02020603050405020304" pitchFamily="18" charset="0"/>
                 <a:cs typeface="Times New Roman" panose="02020603050405020304" pitchFamily="18" charset="0"/>
               </a:rPr>
               <a:t>Occupational Functioning: </a:t>
             </a:r>
             <a:r>
-              <a:rPr lang="en-US" sz="1600" dirty="0">
+              <a:rPr lang="en-US" sz="1800" dirty="0">
                 <a:latin typeface="Times New Roman" panose="02020603050405020304" pitchFamily="18" charset="0"/>
                 <a:cs typeface="Times New Roman" panose="02020603050405020304" pitchFamily="18" charset="0"/>
               </a:rPr>
@@ -13023,7 +13023,7 @@
               </a:lnSpc>
             </a:pPr>
             <a:r>
-              <a:rPr lang="en-US" sz="1600" b="1" dirty="0">
+              <a:rPr lang="en-US" sz="1800" b="1" dirty="0">
                 <a:latin typeface="Times New Roman" panose="02020603050405020304" pitchFamily="18" charset="0"/>
                 <a:cs typeface="Times New Roman" panose="02020603050405020304" pitchFamily="18" charset="0"/>
               </a:rPr>
@@ -13037,7 +13037,7 @@
               </a:lnSpc>
             </a:pPr>
             <a:r>
-              <a:rPr lang="en-US" sz="1600" dirty="0">
+              <a:rPr lang="en-US" sz="1800" dirty="0">
                 <a:latin typeface="Times New Roman" panose="02020603050405020304" pitchFamily="18" charset="0"/>
                 <a:cs typeface="Times New Roman" panose="02020603050405020304" pitchFamily="18" charset="0"/>
               </a:rPr>
@@ -13053,7 +13053,7 @@
               <a:buChar char="•"/>
             </a:pPr>
             <a:r>
-              <a:rPr lang="en-US" sz="1600" dirty="0">
+              <a:rPr lang="en-US" sz="1800" dirty="0">
                 <a:latin typeface="Times New Roman" panose="02020603050405020304" pitchFamily="18" charset="0"/>
                 <a:cs typeface="Times New Roman" panose="02020603050405020304" pitchFamily="18" charset="0"/>
               </a:rPr>
@@ -13069,7 +13069,7 @@
               <a:buChar char="•"/>
             </a:pPr>
             <a:r>
-              <a:rPr lang="en-US" sz="1600" dirty="0">
+              <a:rPr lang="en-US" sz="1800" dirty="0">
                 <a:latin typeface="Times New Roman" panose="02020603050405020304" pitchFamily="18" charset="0"/>
                 <a:cs typeface="Times New Roman" panose="02020603050405020304" pitchFamily="18" charset="0"/>
               </a:rPr>
@@ -13085,7 +13085,7 @@
               <a:buChar char="•"/>
             </a:pPr>
             <a:r>
-              <a:rPr lang="en-US" sz="1600" dirty="0">
+              <a:rPr lang="en-US" sz="1800" dirty="0">
                 <a:latin typeface="Times New Roman" panose="02020603050405020304" pitchFamily="18" charset="0"/>
                 <a:cs typeface="Times New Roman" panose="02020603050405020304" pitchFamily="18" charset="0"/>
               </a:rPr>
@@ -13101,7 +13101,7 @@
               <a:buChar char="•"/>
             </a:pPr>
             <a:r>
-              <a:rPr lang="en-US" sz="1600" dirty="0">
+              <a:rPr lang="en-US" sz="1800" dirty="0">
                 <a:latin typeface="Times New Roman" panose="02020603050405020304" pitchFamily="18" charset="0"/>
                 <a:cs typeface="Times New Roman" panose="02020603050405020304" pitchFamily="18" charset="0"/>
               </a:rPr>
@@ -13117,7 +13117,7 @@
               <a:buChar char="•"/>
             </a:pPr>
             <a:r>
-              <a:rPr lang="en-US" sz="1600" dirty="0">
+              <a:rPr lang="en-US" sz="1800" dirty="0">
                 <a:latin typeface="Times New Roman" panose="02020603050405020304" pitchFamily="18" charset="0"/>
                 <a:cs typeface="Times New Roman" panose="02020603050405020304" pitchFamily="18" charset="0"/>
               </a:rPr>
@@ -13133,7 +13133,7 @@
               <a:buChar char="•"/>
             </a:pPr>
             <a:r>
-              <a:rPr lang="en-US" sz="1600" dirty="0">
+              <a:rPr lang="en-US" sz="1800" dirty="0">
                 <a:latin typeface="Times New Roman" panose="02020603050405020304" pitchFamily="18" charset="0"/>
                 <a:cs typeface="Times New Roman" panose="02020603050405020304" pitchFamily="18" charset="0"/>
               </a:rPr>

</xml_diff>